<commit_message>
docs(4th): S6/S7 표본 확대 정정 — workspace만 캡, 나머지는 held-out 풀 전수
eval_split.per_suite 확인: banking 45/45·slack 35/35·travel 28/28은 held-out
후보 풀 전수, workspace만 392쌍 중 45 샘플(40 완주). --limit_pairs 45의
suite별 자동 캡핑 결과(feedback 2.1.4). "4개 suite 풀 전부"라는 뭉뚱그린
서술을 정확히 고침. script + build_deck_4th.py + pptx 재생성.

Co-Authored-By: Claude Sonnet 5 <noreply@anthropic.com>
Claude-Session: https://claude.ai/code/session_01V7E9vi4ameJCetACyCoxpn
</commit_message>
<xml_diff>
--- a/docs/presentation/IPI_Head_Separation_PoC_4th [26-09-XX].pptx
+++ b/docs/presentation/IPI_Head_Separation_PoC_4th [26-09-XX].pptx
@@ -12878,7 +12878,40 @@
                 <a:ea typeface="Malgun Gothic"/>
                 <a:cs typeface="Malgun Gothic"/>
               </a:rPr>
-              <a:t>4개 suite held-out 후보 풀 전부 사용</a:t>
+              <a:t>banking/slack/travel은 held-out 풀 전수</a:t>
+            </a:r>
+            <a:r>
+              <a:rPr sz="1350" b="0">
+                <a:solidFill>
+                  <a:srgbClr val="565C66"/>
+                </a:solidFill>
+                <a:latin typeface="Malgun Gothic"/>
+                <a:ea typeface="Malgun Gothic"/>
+                <a:cs typeface="Malgun Gothic"/>
+              </a:rPr>
+              <a:t>, workspace만 풀 392쌍 중 45로 캡(</a:t>
+            </a:r>
+            <a:r>
+              <a:rPr sz="1100" b="0">
+                <a:solidFill>
+                  <a:srgbClr val="565C66"/>
+                </a:solidFill>
+                <a:latin typeface="Consolas"/>
+                <a:ea typeface="Consolas"/>
+                <a:cs typeface="Consolas"/>
+              </a:rPr>
+              <a:t>--limit_pairs 45</a:t>
+            </a:r>
+            <a:r>
+              <a:rPr sz="1350" b="0">
+                <a:solidFill>
+                  <a:srgbClr val="565C66"/>
+                </a:solidFill>
+                <a:latin typeface="Malgun Gothic"/>
+                <a:ea typeface="Malgun Gothic"/>
+                <a:cs typeface="Malgun Gothic"/>
+              </a:rPr>
+              <a:t>)</a:t>
             </a:r>
           </a:p>
         </p:txBody>
@@ -13022,7 +13055,7 @@
                 <a:ea typeface="Malgun Gothic"/>
                 <a:cs typeface="Malgun Gothic"/>
               </a:rPr>
-              <a:t>Qwen2.5-32B 4-suite 전수 확대 (n=148)</a:t>
+              <a:t>Qwen2.5-32B 4-suite held-out 풀 확대 (n=148)</a:t>
             </a:r>
           </a:p>
         </p:txBody>
@@ -13037,7 +13070,7 @@
         </p:nvGraphicFramePr>
         <p:xfrm>
           <a:off x="640080" y="1691640"/>
-          <a:ext cx="10908787" cy="2359152"/>
+          <a:ext cx="10908788" cy="2359152"/>
         </p:xfrm>
         <a:graphic>
           <a:graphicData uri="http://schemas.openxmlformats.org/drawingml/2006/table">
@@ -13046,13 +13079,13 @@
                 <a:tableStyleId>{5C22544A-7EE6-4342-B048-85BDC9FD1C3A}</a:tableStyleId>
               </a:tblPr>
               <a:tblGrid>
-                <a:gridCol w="1939340"/>
-                <a:gridCol w="727252"/>
-                <a:gridCol w="1648439"/>
-                <a:gridCol w="1648439"/>
-                <a:gridCol w="1648439"/>
-                <a:gridCol w="1648439"/>
-                <a:gridCol w="1648439"/>
+                <a:gridCol w="1571605"/>
+                <a:gridCol w="2126289"/>
+                <a:gridCol w="1432934"/>
+                <a:gridCol w="1432934"/>
+                <a:gridCol w="1432934"/>
+                <a:gridCol w="1432934"/>
+                <a:gridCol w="1479158"/>
               </a:tblGrid>
               <a:tr h="347472">
                 <a:tc>
@@ -13089,13 +13122,13 @@
                     <a:bodyPr wrap="square"/>
                     <a:lstStyle/>
                     <a:p>
-                      <a:pPr algn="ctr">
+                      <a:pPr algn="l">
                         <a:lnSpc>
                           <a:spcPct val="100000"/>
                         </a:lnSpc>
                       </a:pPr>
                       <a:r>
-                        <a:rPr sz="1050" b="1">
+                        <a:rPr sz="950" b="1">
                           <a:solidFill>
                             <a:srgbClr val="8B9099"/>
                           </a:solidFill>
@@ -13103,7 +13136,7 @@
                           <a:ea typeface="Malgun Gothic"/>
                           <a:cs typeface="Malgun Gothic"/>
                         </a:rPr>
-                        <a:t>n</a:t>
+                        <a:t>n / held-out 풀</a:t>
                       </a:r>
                     </a:p>
                   </a:txBody>
@@ -13294,13 +13327,13 @@
                     <a:bodyPr wrap="square"/>
                     <a:lstStyle/>
                     <a:p>
-                      <a:pPr algn="ctr">
-                        <a:lnSpc>
-                          <a:spcPct val="115000"/>
-                        </a:lnSpc>
-                      </a:pPr>
-                      <a:r>
-                        <a:rPr sz="1050" b="0">
+                      <a:pPr algn="l">
+                        <a:lnSpc>
+                          <a:spcPct val="115000"/>
+                        </a:lnSpc>
+                      </a:pPr>
+                      <a:r>
+                        <a:rPr sz="950" b="0">
                           <a:solidFill>
                             <a:srgbClr val="565C66"/>
                           </a:solidFill>
@@ -13308,7 +13341,7 @@
                           <a:ea typeface="Malgun Gothic"/>
                           <a:cs typeface="Malgun Gothic"/>
                         </a:rPr>
-                        <a:t>45</a:t>
+                        <a:t>45 / 45  전수</a:t>
                       </a:r>
                     </a:p>
                   </a:txBody>
@@ -13499,13 +13532,13 @@
                     <a:bodyPr wrap="square"/>
                     <a:lstStyle/>
                     <a:p>
-                      <a:pPr algn="ctr">
-                        <a:lnSpc>
-                          <a:spcPct val="115000"/>
-                        </a:lnSpc>
-                      </a:pPr>
-                      <a:r>
-                        <a:rPr sz="1050" b="0">
+                      <a:pPr algn="l">
+                        <a:lnSpc>
+                          <a:spcPct val="115000"/>
+                        </a:lnSpc>
+                      </a:pPr>
+                      <a:r>
+                        <a:rPr sz="950" b="0">
                           <a:solidFill>
                             <a:srgbClr val="565C66"/>
                           </a:solidFill>
@@ -13513,7 +13546,7 @@
                           <a:ea typeface="Malgun Gothic"/>
                           <a:cs typeface="Malgun Gothic"/>
                         </a:rPr>
-                        <a:t>35</a:t>
+                        <a:t>35 / 35  전수</a:t>
                       </a:r>
                     </a:p>
                   </a:txBody>
@@ -13704,13 +13737,13 @@
                     <a:bodyPr wrap="square"/>
                     <a:lstStyle/>
                     <a:p>
-                      <a:pPr algn="ctr">
-                        <a:lnSpc>
-                          <a:spcPct val="115000"/>
-                        </a:lnSpc>
-                      </a:pPr>
-                      <a:r>
-                        <a:rPr sz="1050" b="0">
+                      <a:pPr algn="l">
+                        <a:lnSpc>
+                          <a:spcPct val="115000"/>
+                        </a:lnSpc>
+                      </a:pPr>
+                      <a:r>
+                        <a:rPr sz="950" b="0">
                           <a:solidFill>
                             <a:srgbClr val="565C66"/>
                           </a:solidFill>
@@ -13718,7 +13751,7 @@
                           <a:ea typeface="Malgun Gothic"/>
                           <a:cs typeface="Malgun Gothic"/>
                         </a:rPr>
-                        <a:t>28</a:t>
+                        <a:t>28 / 28  전수</a:t>
                       </a:r>
                     </a:p>
                   </a:txBody>
@@ -13909,13 +13942,24 @@
                     <a:bodyPr wrap="square"/>
                     <a:lstStyle/>
                     <a:p>
-                      <a:pPr algn="ctr">
-                        <a:lnSpc>
-                          <a:spcPct val="115000"/>
-                        </a:lnSpc>
-                      </a:pPr>
-                      <a:r>
-                        <a:rPr sz="1050" b="0">
+                      <a:pPr algn="l">
+                        <a:lnSpc>
+                          <a:spcPct val="115000"/>
+                        </a:lnSpc>
+                      </a:pPr>
+                      <a:r>
+                        <a:rPr sz="950" b="1">
+                          <a:solidFill>
+                            <a:srgbClr val="C1442A"/>
+                          </a:solidFill>
+                          <a:latin typeface="Malgun Gothic"/>
+                          <a:ea typeface="Malgun Gothic"/>
+                          <a:cs typeface="Malgun Gothic"/>
+                        </a:rPr>
+                        <a:t>40 / 392</a:t>
+                      </a:r>
+                      <a:r>
+                        <a:rPr sz="950" b="0">
                           <a:solidFill>
                             <a:srgbClr val="565C66"/>
                           </a:solidFill>
@@ -13923,7 +13967,7 @@
                           <a:ea typeface="Malgun Gothic"/>
                           <a:cs typeface="Malgun Gothic"/>
                         </a:rPr>
-                        <a:t>40</a:t>
+                        <a:t>  (45 샘플)</a:t>
                       </a:r>
                     </a:p>
                   </a:txBody>
@@ -14114,13 +14158,13 @@
                     <a:bodyPr wrap="square"/>
                     <a:lstStyle/>
                     <a:p>
-                      <a:pPr algn="ctr">
-                        <a:lnSpc>
-                          <a:spcPct val="115000"/>
-                        </a:lnSpc>
-                      </a:pPr>
-                      <a:r>
-                        <a:rPr sz="1050" b="1">
+                      <a:pPr algn="l">
+                        <a:lnSpc>
+                          <a:spcPct val="115000"/>
+                        </a:lnSpc>
+                      </a:pPr>
+                      <a:r>
+                        <a:rPr sz="950" b="1">
                           <a:solidFill>
                             <a:srgbClr val="16181D"/>
                           </a:solidFill>
@@ -14296,8 +14340,8 @@
         </p:nvSpPr>
         <p:spPr>
           <a:xfrm>
-            <a:off x="640080" y="4617720"/>
-            <a:ext cx="10908792" cy="1463040"/>
+            <a:off x="640080" y="4224528"/>
+            <a:ext cx="10908792" cy="1874519"/>
           </a:xfrm>
           <a:prstGeom prst="roundRect">
             <a:avLst>
@@ -14340,8 +14384,8 @@
         </p:nvSpPr>
         <p:spPr>
           <a:xfrm>
-            <a:off x="914400" y="4782312"/>
-            <a:ext cx="10360152" cy="1188720"/>
+            <a:off x="914400" y="4389120"/>
+            <a:ext cx="10360152" cy="1600200"/>
           </a:xfrm>
           <a:prstGeom prst="rect">
             <a:avLst/>
@@ -14412,6 +14456,27 @@
                 <a:cs typeface="Malgun Gothic"/>
               </a:rPr>
               <a:t> — held-out 35쌍 전수 기준 성공한 공격 8건 중 5건을 knockout이 못 막음(억제 3, persist 5). banking/travel/workspace는 완벽 억제(0%).</a:t>
+            </a:r>
+          </a:p>
+          <a:p>
+            <a:pPr algn="l">
+              <a:lnSpc>
+                <a:spcPct val="125000"/>
+              </a:lnSpc>
+              <a:spcBef>
+                <a:spcPts val="600"/>
+              </a:spcBef>
+            </a:pPr>
+            <a:r>
+              <a:rPr sz="1050" b="0">
+                <a:solidFill>
+                  <a:srgbClr val="8B9099"/>
+                </a:solidFill>
+                <a:latin typeface="Malgun Gothic"/>
+                <a:ea typeface="Malgun Gothic"/>
+                <a:cs typeface="Malgun Gothic"/>
+              </a:rPr>
+              <a:t>banking·slack·travel은 held-out 풀 전수라 표본 논란 없음. workspace는 392쌍 중 40쌍만 봤지만 k0 ASR 자체가 0%라 결론에 영향 없음.</a:t>
             </a:r>
           </a:p>
         </p:txBody>

</xml_diff>

<commit_message>
docs(4th): S11 재작성 — 32B 4bit는 GPU 고정 시 결정론적 (A6000/Blackwell same-GPU 반복)
feedback 2.1.20 신설 + 2.1.17에 정정 註. 핵심:
- 32B nf4dq는 GPU 고정 시 완전 결정론적 (A6000 3회·Blackwell 5회 각각 35쌍 일치).
  기존 "run-to-run 비결정성" 진단은 오진 → 실제는 A6000↔Blackwell 아키텍처 차이.
- Blackwell sm_120 bnb nf4 커널이 32B 손상 (slack k0_util 0.286→0.09). A6000 nf4dq는
  bf16과 baseline 일치 → 신뢰 가능.
- 스케일 효과: bf16 기준 그대로 + A6000 nf4dq(순효과 0)로 보강.
- S11 표에 slack k0_util 열 추가, S12 요약·다음단계에서 "비결정성 규명" 항목 해소 처리.
- S14 한계 1번 해소 (원인 = Blackwell 커널).

script + build_deck_4th.py + pptx + feedback 2.1.17/2.1.20 반영.

Co-Authored-By: Claude Sonnet 5 <noreply@anthropic.com>
Claude-Session: https://claude.ai/code/session_01V7E9vi4ameJCetACyCoxpn
</commit_message>
<xml_diff>
--- a/docs/presentation/IPI_Head_Separation_PoC_4th [26-09-XX].pptx
+++ b/docs/presentation/IPI_Head_Separation_PoC_4th [26-09-XX].pptx
@@ -4528,7 +4528,7 @@
               </a:lnSpc>
             </a:pPr>
             <a:r>
-              <a:rPr sz="2600" b="1">
+              <a:rPr sz="2300" b="1">
                 <a:solidFill>
                   <a:srgbClr val="16181D"/>
                 </a:solidFill>
@@ -4536,7 +4536,7 @@
                 <a:ea typeface="Malgun Gothic"/>
                 <a:cs typeface="Malgun Gothic"/>
               </a:rPr>
-              <a:t>32B: fp4 / nf4dq (비결정적) / bf16</a:t>
+              <a:t>32B: nf4dq는 GPU 의존 · bf16으로 스케일 효과 확정</a:t>
             </a:r>
           </a:p>
         </p:txBody>
@@ -4551,7 +4551,7 @@
         </p:nvGraphicFramePr>
         <p:xfrm>
           <a:off x="640080" y="1691640"/>
-          <a:ext cx="10908792" cy="2048256"/>
+          <a:ext cx="10908790" cy="2048256"/>
         </p:xfrm>
         <a:graphic>
           <a:graphicData uri="http://schemas.openxmlformats.org/drawingml/2006/table">
@@ -4560,13 +4560,13 @@
                 <a:tableStyleId>{5C22544A-7EE6-4342-B048-85BDC9FD1C3A}</a:tableStyleId>
               </a:tblPr>
               <a:tblGrid>
-                <a:gridCol w="2468880"/>
-                <a:gridCol w="2651760"/>
-                <a:gridCol w="1280160"/>
-                <a:gridCol w="1280160"/>
-                <a:gridCol w="914400"/>
-                <a:gridCol w="1280160"/>
-                <a:gridCol w="1033272"/>
+                <a:gridCol w="2473139"/>
+                <a:gridCol w="2742936"/>
+                <a:gridCol w="1124154"/>
+                <a:gridCol w="1124154"/>
+                <a:gridCol w="1393951"/>
+                <a:gridCol w="1034221"/>
+                <a:gridCol w="1016235"/>
               </a:tblGrid>
               <a:tr h="365760">
                 <a:tc>
@@ -4580,6 +4580,64 @@
                         </a:lnSpc>
                       </a:pPr>
                       <a:r>
+                        <a:rPr sz="950" b="1">
+                          <a:solidFill>
+                            <a:srgbClr val="8B9099"/>
+                          </a:solidFill>
+                          <a:latin typeface="Malgun Gothic"/>
+                          <a:ea typeface="Malgun Gothic"/>
+                          <a:cs typeface="Malgun Gothic"/>
+                        </a:rPr>
+                        <a:t>실행</a:t>
+                      </a:r>
+                    </a:p>
+                  </a:txBody>
+                  <a:tcPr marL="82296" marR="82296" marT="41148" marB="41148" anchor="ctr">
+                    <a:solidFill>
+                      <a:srgbClr val="E9EAED"/>
+                    </a:solidFill>
+                  </a:tcPr>
+                </a:tc>
+                <a:tc>
+                  <a:txBody>
+                    <a:bodyPr wrap="square"/>
+                    <a:lstStyle/>
+                    <a:p>
+                      <a:pPr algn="l">
+                        <a:lnSpc>
+                          <a:spcPct val="100000"/>
+                        </a:lnSpc>
+                      </a:pPr>
+                      <a:r>
+                        <a:rPr sz="900" b="1">
+                          <a:solidFill>
+                            <a:srgbClr val="8B9099"/>
+                          </a:solidFill>
+                          <a:latin typeface="Malgun Gothic"/>
+                          <a:ea typeface="Malgun Gothic"/>
+                          <a:cs typeface="Malgun Gothic"/>
+                        </a:rPr>
+                        <a:t>GPU / quant</a:t>
+                      </a:r>
+                    </a:p>
+                  </a:txBody>
+                  <a:tcPr marL="82296" marR="82296" marT="41148" marB="41148" anchor="ctr">
+                    <a:solidFill>
+                      <a:srgbClr val="E9EAED"/>
+                    </a:solidFill>
+                  </a:tcPr>
+                </a:tc>
+                <a:tc>
+                  <a:txBody>
+                    <a:bodyPr wrap="square"/>
+                    <a:lstStyle/>
+                    <a:p>
+                      <a:pPr algn="r">
+                        <a:lnSpc>
+                          <a:spcPct val="100000"/>
+                        </a:lnSpc>
+                      </a:pPr>
+                      <a:r>
                         <a:rPr sz="1000" b="1">
                           <a:solidFill>
                             <a:srgbClr val="8B9099"/>
@@ -4588,7 +4646,7 @@
                           <a:ea typeface="Malgun Gothic"/>
                           <a:cs typeface="Malgun Gothic"/>
                         </a:rPr>
-                        <a:t>실행</a:t>
+                        <a:t>slack k0</a:t>
                       </a:r>
                     </a:p>
                   </a:txBody>
@@ -4603,12 +4661,41 @@
                     <a:bodyPr wrap="square"/>
                     <a:lstStyle/>
                     <a:p>
-                      <a:pPr algn="l">
+                      <a:pPr algn="r">
                         <a:lnSpc>
                           <a:spcPct val="100000"/>
                         </a:lnSpc>
                       </a:pPr>
                       <a:r>
+                        <a:rPr sz="1000" b="1">
+                          <a:solidFill>
+                            <a:srgbClr val="8B9099"/>
+                          </a:solidFill>
+                          <a:latin typeface="Malgun Gothic"/>
+                          <a:ea typeface="Malgun Gothic"/>
+                          <a:cs typeface="Malgun Gothic"/>
+                        </a:rPr>
+                        <a:t>slack kN</a:t>
+                      </a:r>
+                    </a:p>
+                  </a:txBody>
+                  <a:tcPr marL="82296" marR="82296" marT="41148" marB="41148" anchor="ctr">
+                    <a:solidFill>
+                      <a:srgbClr val="E9EAED"/>
+                    </a:solidFill>
+                  </a:tcPr>
+                </a:tc>
+                <a:tc>
+                  <a:txBody>
+                    <a:bodyPr wrap="square"/>
+                    <a:lstStyle/>
+                    <a:p>
+                      <a:pPr algn="r">
+                        <a:lnSpc>
+                          <a:spcPct val="100000"/>
+                        </a:lnSpc>
+                      </a:pPr>
+                      <a:r>
                         <a:rPr sz="950" b="1">
                           <a:solidFill>
                             <a:srgbClr val="8B9099"/>
@@ -4617,94 +4704,7 @@
                           <a:ea typeface="Malgun Gothic"/>
                           <a:cs typeface="Malgun Gothic"/>
                         </a:rPr>
-                        <a:t>GPU / quant</a:t>
-                      </a:r>
-                    </a:p>
-                  </a:txBody>
-                  <a:tcPr marL="82296" marR="82296" marT="41148" marB="41148" anchor="ctr">
-                    <a:solidFill>
-                      <a:srgbClr val="E9EAED"/>
-                    </a:solidFill>
-                  </a:tcPr>
-                </a:tc>
-                <a:tc>
-                  <a:txBody>
-                    <a:bodyPr wrap="square"/>
-                    <a:lstStyle/>
-                    <a:p>
-                      <a:pPr algn="r">
-                        <a:lnSpc>
-                          <a:spcPct val="100000"/>
-                        </a:lnSpc>
-                      </a:pPr>
-                      <a:r>
-                        <a:rPr sz="1000" b="1">
-                          <a:solidFill>
-                            <a:srgbClr val="8B9099"/>
-                          </a:solidFill>
-                          <a:latin typeface="Malgun Gothic"/>
-                          <a:ea typeface="Malgun Gothic"/>
-                          <a:cs typeface="Malgun Gothic"/>
-                        </a:rPr>
-                        <a:t>slack k0</a:t>
-                      </a:r>
-                    </a:p>
-                  </a:txBody>
-                  <a:tcPr marL="82296" marR="82296" marT="41148" marB="41148" anchor="ctr">
-                    <a:solidFill>
-                      <a:srgbClr val="E9EAED"/>
-                    </a:solidFill>
-                  </a:tcPr>
-                </a:tc>
-                <a:tc>
-                  <a:txBody>
-                    <a:bodyPr wrap="square"/>
-                    <a:lstStyle/>
-                    <a:p>
-                      <a:pPr algn="r">
-                        <a:lnSpc>
-                          <a:spcPct val="100000"/>
-                        </a:lnSpc>
-                      </a:pPr>
-                      <a:r>
-                        <a:rPr sz="1000" b="1">
-                          <a:solidFill>
-                            <a:srgbClr val="8B9099"/>
-                          </a:solidFill>
-                          <a:latin typeface="Malgun Gothic"/>
-                          <a:ea typeface="Malgun Gothic"/>
-                          <a:cs typeface="Malgun Gothic"/>
-                        </a:rPr>
-                        <a:t>slack kN</a:t>
-                      </a:r>
-                    </a:p>
-                  </a:txBody>
-                  <a:tcPr marL="82296" marR="82296" marT="41148" marB="41148" anchor="ctr">
-                    <a:solidFill>
-                      <a:srgbClr val="E9EAED"/>
-                    </a:solidFill>
-                  </a:tcPr>
-                </a:tc>
-                <a:tc>
-                  <a:txBody>
-                    <a:bodyPr wrap="square"/>
-                    <a:lstStyle/>
-                    <a:p>
-                      <a:pPr algn="ctr">
-                        <a:lnSpc>
-                          <a:spcPct val="100000"/>
-                        </a:lnSpc>
-                      </a:pPr>
-                      <a:r>
-                        <a:rPr sz="1000" b="1">
-                          <a:solidFill>
-                            <a:srgbClr val="8B9099"/>
-                          </a:solidFill>
-                          <a:latin typeface="Malgun Gothic"/>
-                          <a:ea typeface="Malgun Gothic"/>
-                          <a:cs typeface="Malgun Gothic"/>
-                        </a:rPr>
-                        <a:t>supp</a:t>
+                        <a:t>slack k0_util</a:t>
                       </a:r>
                     </a:p>
                   </a:txBody>
@@ -4785,6 +4785,64 @@
                         </a:lnSpc>
                       </a:pPr>
                       <a:r>
+                        <a:rPr sz="950" b="0">
+                          <a:solidFill>
+                            <a:srgbClr val="565C66"/>
+                          </a:solidFill>
+                          <a:latin typeface="Malgun Gothic"/>
+                          <a:ea typeface="Malgun Gothic"/>
+                          <a:cs typeface="Malgun Gothic"/>
+                        </a:rPr>
+                        <a:t>32B nf4dq  (×3 동일)</a:t>
+                      </a:r>
+                    </a:p>
+                  </a:txBody>
+                  <a:tcPr marL="82296" marR="82296" marT="41148" marB="41148" anchor="ctr">
+                    <a:solidFill>
+                      <a:srgbClr val="FFFFFF"/>
+                    </a:solidFill>
+                  </a:tcPr>
+                </a:tc>
+                <a:tc>
+                  <a:txBody>
+                    <a:bodyPr wrap="square"/>
+                    <a:lstStyle/>
+                    <a:p>
+                      <a:pPr algn="l">
+                        <a:lnSpc>
+                          <a:spcPct val="115000"/>
+                        </a:lnSpc>
+                      </a:pPr>
+                      <a:r>
+                        <a:rPr sz="900" b="0">
+                          <a:solidFill>
+                            <a:srgbClr val="565C66"/>
+                          </a:solidFill>
+                          <a:latin typeface="Malgun Gothic"/>
+                          <a:ea typeface="Malgun Gothic"/>
+                          <a:cs typeface="Malgun Gothic"/>
+                        </a:rPr>
+                        <a:t>A6000 sm_86 / nf4dq</a:t>
+                      </a:r>
+                    </a:p>
+                  </a:txBody>
+                  <a:tcPr marL="82296" marR="82296" marT="41148" marB="41148" anchor="ctr">
+                    <a:solidFill>
+                      <a:srgbClr val="FFFFFF"/>
+                    </a:solidFill>
+                  </a:tcPr>
+                </a:tc>
+                <a:tc>
+                  <a:txBody>
+                    <a:bodyPr wrap="square"/>
+                    <a:lstStyle/>
+                    <a:p>
+                      <a:pPr algn="r">
+                        <a:lnSpc>
+                          <a:spcPct val="115000"/>
+                        </a:lnSpc>
+                      </a:pPr>
+                      <a:r>
                         <a:rPr sz="1000" b="0">
                           <a:solidFill>
                             <a:srgbClr val="565C66"/>
@@ -4793,7 +4851,7 @@
                           <a:ea typeface="Malgun Gothic"/>
                           <a:cs typeface="Malgun Gothic"/>
                         </a:rPr>
-                        <a:t>32B nf4dq #1</a:t>
+                        <a:t>0.229</a:t>
                       </a:r>
                     </a:p>
                   </a:txBody>
@@ -4808,7 +4866,36 @@
                     <a:bodyPr wrap="square"/>
                     <a:lstStyle/>
                     <a:p>
-                      <a:pPr algn="l">
+                      <a:pPr algn="r">
+                        <a:lnSpc>
+                          <a:spcPct val="115000"/>
+                        </a:lnSpc>
+                      </a:pPr>
+                      <a:r>
+                        <a:rPr sz="1000" b="0">
+                          <a:solidFill>
+                            <a:srgbClr val="565C66"/>
+                          </a:solidFill>
+                          <a:latin typeface="Malgun Gothic"/>
+                          <a:ea typeface="Malgun Gothic"/>
+                          <a:cs typeface="Malgun Gothic"/>
+                        </a:rPr>
+                        <a:t>0.229</a:t>
+                      </a:r>
+                    </a:p>
+                  </a:txBody>
+                  <a:tcPr marL="82296" marR="82296" marT="41148" marB="41148" anchor="ctr">
+                    <a:solidFill>
+                      <a:srgbClr val="FFFFFF"/>
+                    </a:solidFill>
+                  </a:tcPr>
+                </a:tc>
+                <a:tc>
+                  <a:txBody>
+                    <a:bodyPr wrap="square"/>
+                    <a:lstStyle/>
+                    <a:p>
+                      <a:pPr algn="r">
                         <a:lnSpc>
                           <a:spcPct val="115000"/>
                         </a:lnSpc>
@@ -4822,94 +4909,7 @@
                           <a:ea typeface="Malgun Gothic"/>
                           <a:cs typeface="Malgun Gothic"/>
                         </a:rPr>
-                        <a:t>A6000 / nf4dq</a:t>
-                      </a:r>
-                    </a:p>
-                  </a:txBody>
-                  <a:tcPr marL="82296" marR="82296" marT="41148" marB="41148" anchor="ctr">
-                    <a:solidFill>
-                      <a:srgbClr val="FFFFFF"/>
-                    </a:solidFill>
-                  </a:tcPr>
-                </a:tc>
-                <a:tc>
-                  <a:txBody>
-                    <a:bodyPr wrap="square"/>
-                    <a:lstStyle/>
-                    <a:p>
-                      <a:pPr algn="r">
-                        <a:lnSpc>
-                          <a:spcPct val="115000"/>
-                        </a:lnSpc>
-                      </a:pPr>
-                      <a:r>
-                        <a:rPr sz="1000" b="0">
-                          <a:solidFill>
-                            <a:srgbClr val="565C66"/>
-                          </a:solidFill>
-                          <a:latin typeface="Malgun Gothic"/>
-                          <a:ea typeface="Malgun Gothic"/>
-                          <a:cs typeface="Malgun Gothic"/>
-                        </a:rPr>
-                        <a:t>0.229</a:t>
-                      </a:r>
-                    </a:p>
-                  </a:txBody>
-                  <a:tcPr marL="82296" marR="82296" marT="41148" marB="41148" anchor="ctr">
-                    <a:solidFill>
-                      <a:srgbClr val="FFFFFF"/>
-                    </a:solidFill>
-                  </a:tcPr>
-                </a:tc>
-                <a:tc>
-                  <a:txBody>
-                    <a:bodyPr wrap="square"/>
-                    <a:lstStyle/>
-                    <a:p>
-                      <a:pPr algn="r">
-                        <a:lnSpc>
-                          <a:spcPct val="115000"/>
-                        </a:lnSpc>
-                      </a:pPr>
-                      <a:r>
-                        <a:rPr sz="1000" b="0">
-                          <a:solidFill>
-                            <a:srgbClr val="565C66"/>
-                          </a:solidFill>
-                          <a:latin typeface="Malgun Gothic"/>
-                          <a:ea typeface="Malgun Gothic"/>
-                          <a:cs typeface="Malgun Gothic"/>
-                        </a:rPr>
-                        <a:t>0.229</a:t>
-                      </a:r>
-                    </a:p>
-                  </a:txBody>
-                  <a:tcPr marL="82296" marR="82296" marT="41148" marB="41148" anchor="ctr">
-                    <a:solidFill>
-                      <a:srgbClr val="FFFFFF"/>
-                    </a:solidFill>
-                  </a:tcPr>
-                </a:tc>
-                <a:tc>
-                  <a:txBody>
-                    <a:bodyPr wrap="square"/>
-                    <a:lstStyle/>
-                    <a:p>
-                      <a:pPr algn="ctr">
-                        <a:lnSpc>
-                          <a:spcPct val="115000"/>
-                        </a:lnSpc>
-                      </a:pPr>
-                      <a:r>
-                        <a:rPr sz="1000" b="0">
-                          <a:solidFill>
-                            <a:srgbClr val="565C66"/>
-                          </a:solidFill>
-                          <a:latin typeface="Malgun Gothic"/>
-                          <a:ea typeface="Malgun Gothic"/>
-                          <a:cs typeface="Malgun Gothic"/>
-                        </a:rPr>
-                        <a:t>2</a:t>
+                        <a:t>0.286</a:t>
                       </a:r>
                     </a:p>
                   </a:txBody>
@@ -4990,6 +4990,64 @@
                         </a:lnSpc>
                       </a:pPr>
                       <a:r>
+                        <a:rPr sz="950" b="0">
+                          <a:solidFill>
+                            <a:srgbClr val="565C66"/>
+                          </a:solidFill>
+                          <a:latin typeface="Malgun Gothic"/>
+                          <a:ea typeface="Malgun Gothic"/>
+                          <a:cs typeface="Malgun Gothic"/>
+                        </a:rPr>
+                        <a:t>32B nf4dq  (×5 동일)</a:t>
+                      </a:r>
+                    </a:p>
+                  </a:txBody>
+                  <a:tcPr marL="82296" marR="82296" marT="41148" marB="41148" anchor="ctr">
+                    <a:solidFill>
+                      <a:srgbClr val="F7F7F9"/>
+                    </a:solidFill>
+                  </a:tcPr>
+                </a:tc>
+                <a:tc>
+                  <a:txBody>
+                    <a:bodyPr wrap="square"/>
+                    <a:lstStyle/>
+                    <a:p>
+                      <a:pPr algn="l">
+                        <a:lnSpc>
+                          <a:spcPct val="115000"/>
+                        </a:lnSpc>
+                      </a:pPr>
+                      <a:r>
+                        <a:rPr sz="900" b="0">
+                          <a:solidFill>
+                            <a:srgbClr val="565C66"/>
+                          </a:solidFill>
+                          <a:latin typeface="Malgun Gothic"/>
+                          <a:ea typeface="Malgun Gothic"/>
+                          <a:cs typeface="Malgun Gothic"/>
+                        </a:rPr>
+                        <a:t>Blackwell sm_120 / nf4dq</a:t>
+                      </a:r>
+                    </a:p>
+                  </a:txBody>
+                  <a:tcPr marL="82296" marR="82296" marT="41148" marB="41148" anchor="ctr">
+                    <a:solidFill>
+                      <a:srgbClr val="F7F7F9"/>
+                    </a:solidFill>
+                  </a:tcPr>
+                </a:tc>
+                <a:tc>
+                  <a:txBody>
+                    <a:bodyPr wrap="square"/>
+                    <a:lstStyle/>
+                    <a:p>
+                      <a:pPr algn="r">
+                        <a:lnSpc>
+                          <a:spcPct val="115000"/>
+                        </a:lnSpc>
+                      </a:pPr>
+                      <a:r>
                         <a:rPr sz="1000" b="0">
                           <a:solidFill>
                             <a:srgbClr val="565C66"/>
@@ -4998,7 +5056,7 @@
                           <a:ea typeface="Malgun Gothic"/>
                           <a:cs typeface="Malgun Gothic"/>
                         </a:rPr>
-                        <a:t>32B nf4dq #2</a:t>
+                        <a:t>0.171</a:t>
                       </a:r>
                     </a:p>
                   </a:txBody>
@@ -5013,13 +5071,13 @@
                     <a:bodyPr wrap="square"/>
                     <a:lstStyle/>
                     <a:p>
-                      <a:pPr algn="l">
-                        <a:lnSpc>
-                          <a:spcPct val="115000"/>
-                        </a:lnSpc>
-                      </a:pPr>
-                      <a:r>
-                        <a:rPr sz="950" b="0">
+                      <a:pPr algn="r">
+                        <a:lnSpc>
+                          <a:spcPct val="115000"/>
+                        </a:lnSpc>
+                      </a:pPr>
+                      <a:r>
+                        <a:rPr sz="1000" b="0">
                           <a:solidFill>
                             <a:srgbClr val="565C66"/>
                           </a:solidFill>
@@ -5027,7 +5085,7 @@
                           <a:ea typeface="Malgun Gothic"/>
                           <a:cs typeface="Malgun Gothic"/>
                         </a:rPr>
-                        <a:t>Blackwell / nf4dq</a:t>
+                        <a:t>0.114</a:t>
                       </a:r>
                     </a:p>
                   </a:txBody>
@@ -5048,73 +5106,15 @@
                         </a:lnSpc>
                       </a:pPr>
                       <a:r>
-                        <a:rPr sz="1000" b="0">
-                          <a:solidFill>
-                            <a:srgbClr val="565C66"/>
-                          </a:solidFill>
-                          <a:latin typeface="Malgun Gothic"/>
-                          <a:ea typeface="Malgun Gothic"/>
-                          <a:cs typeface="Malgun Gothic"/>
-                        </a:rPr>
-                        <a:t>0.171</a:t>
-                      </a:r>
-                    </a:p>
-                  </a:txBody>
-                  <a:tcPr marL="82296" marR="82296" marT="41148" marB="41148" anchor="ctr">
-                    <a:solidFill>
-                      <a:srgbClr val="F7F7F9"/>
-                    </a:solidFill>
-                  </a:tcPr>
-                </a:tc>
-                <a:tc>
-                  <a:txBody>
-                    <a:bodyPr wrap="square"/>
-                    <a:lstStyle/>
-                    <a:p>
-                      <a:pPr algn="r">
-                        <a:lnSpc>
-                          <a:spcPct val="115000"/>
-                        </a:lnSpc>
-                      </a:pPr>
-                      <a:r>
-                        <a:rPr sz="1000" b="0">
-                          <a:solidFill>
-                            <a:srgbClr val="565C66"/>
-                          </a:solidFill>
-                          <a:latin typeface="Malgun Gothic"/>
-                          <a:ea typeface="Malgun Gothic"/>
-                          <a:cs typeface="Malgun Gothic"/>
-                        </a:rPr>
-                        <a:t>0.114</a:t>
-                      </a:r>
-                    </a:p>
-                  </a:txBody>
-                  <a:tcPr marL="82296" marR="82296" marT="41148" marB="41148" anchor="ctr">
-                    <a:solidFill>
-                      <a:srgbClr val="F7F7F9"/>
-                    </a:solidFill>
-                  </a:tcPr>
-                </a:tc>
-                <a:tc>
-                  <a:txBody>
-                    <a:bodyPr wrap="square"/>
-                    <a:lstStyle/>
-                    <a:p>
-                      <a:pPr algn="ctr">
-                        <a:lnSpc>
-                          <a:spcPct val="115000"/>
-                        </a:lnSpc>
-                      </a:pPr>
-                      <a:r>
-                        <a:rPr sz="1000" b="0">
-                          <a:solidFill>
-                            <a:srgbClr val="565C66"/>
-                          </a:solidFill>
-                          <a:latin typeface="Malgun Gothic"/>
-                          <a:ea typeface="Malgun Gothic"/>
-                          <a:cs typeface="Malgun Gothic"/>
-                        </a:rPr>
-                        <a:t>2</a:t>
+                        <a:rPr sz="950" b="1">
+                          <a:solidFill>
+                            <a:srgbClr val="C1442A"/>
+                          </a:solidFill>
+                          <a:latin typeface="Malgun Gothic"/>
+                          <a:ea typeface="Malgun Gothic"/>
+                          <a:cs typeface="Malgun Gothic"/>
+                        </a:rPr>
+                        <a:t>0.09</a:t>
                       </a:r>
                     </a:p>
                   </a:txBody>
@@ -5195,15 +5195,102 @@
                         </a:lnSpc>
                       </a:pPr>
                       <a:r>
+                        <a:rPr sz="950" b="1">
+                          <a:solidFill>
+                            <a:srgbClr val="2F6FCE"/>
+                          </a:solidFill>
+                          <a:latin typeface="Malgun Gothic"/>
+                          <a:ea typeface="Malgun Gothic"/>
+                          <a:cs typeface="Malgun Gothic"/>
+                        </a:rPr>
+                        <a:t>32B bf16</a:t>
+                      </a:r>
+                    </a:p>
+                  </a:txBody>
+                  <a:tcPr marL="82296" marR="82296" marT="41148" marB="41148" anchor="ctr">
+                    <a:solidFill>
+                      <a:srgbClr val="FFFFFF"/>
+                    </a:solidFill>
+                  </a:tcPr>
+                </a:tc>
+                <a:tc>
+                  <a:txBody>
+                    <a:bodyPr wrap="square"/>
+                    <a:lstStyle/>
+                    <a:p>
+                      <a:pPr algn="l">
+                        <a:lnSpc>
+                          <a:spcPct val="115000"/>
+                        </a:lnSpc>
+                      </a:pPr>
+                      <a:r>
+                        <a:rPr sz="900" b="1">
+                          <a:solidFill>
+                            <a:srgbClr val="16181D"/>
+                          </a:solidFill>
+                          <a:latin typeface="Malgun Gothic"/>
+                          <a:ea typeface="Malgun Gothic"/>
+                          <a:cs typeface="Malgun Gothic"/>
+                        </a:rPr>
+                        <a:t>A6000 / bf16</a:t>
+                      </a:r>
+                    </a:p>
+                  </a:txBody>
+                  <a:tcPr marL="82296" marR="82296" marT="41148" marB="41148" anchor="ctr">
+                    <a:solidFill>
+                      <a:srgbClr val="FFFFFF"/>
+                    </a:solidFill>
+                  </a:tcPr>
+                </a:tc>
+                <a:tc>
+                  <a:txBody>
+                    <a:bodyPr wrap="square"/>
+                    <a:lstStyle/>
+                    <a:p>
+                      <a:pPr algn="r">
+                        <a:lnSpc>
+                          <a:spcPct val="115000"/>
+                        </a:lnSpc>
+                      </a:pPr>
+                      <a:r>
+                        <a:rPr sz="1000" b="0">
+                          <a:solidFill>
+                            <a:srgbClr val="565C66"/>
+                          </a:solidFill>
+                          <a:latin typeface="Malgun Gothic"/>
+                          <a:ea typeface="Malgun Gothic"/>
+                          <a:cs typeface="Malgun Gothic"/>
+                        </a:rPr>
+                        <a:t>0.257</a:t>
+                      </a:r>
+                    </a:p>
+                  </a:txBody>
+                  <a:tcPr marL="82296" marR="82296" marT="41148" marB="41148" anchor="ctr">
+                    <a:solidFill>
+                      <a:srgbClr val="FFFFFF"/>
+                    </a:solidFill>
+                  </a:tcPr>
+                </a:tc>
+                <a:tc>
+                  <a:txBody>
+                    <a:bodyPr wrap="square"/>
+                    <a:lstStyle/>
+                    <a:p>
+                      <a:pPr algn="r">
+                        <a:lnSpc>
+                          <a:spcPct val="115000"/>
+                        </a:lnSpc>
+                      </a:pPr>
+                      <a:r>
                         <a:rPr sz="1000" b="1">
                           <a:solidFill>
-                            <a:srgbClr val="2F6FCE"/>
-                          </a:solidFill>
-                          <a:latin typeface="Malgun Gothic"/>
-                          <a:ea typeface="Malgun Gothic"/>
-                          <a:cs typeface="Malgun Gothic"/>
-                        </a:rPr>
-                        <a:t>32B bf16</a:t>
+                            <a:srgbClr val="C1442A"/>
+                          </a:solidFill>
+                          <a:latin typeface="Malgun Gothic"/>
+                          <a:ea typeface="Malgun Gothic"/>
+                          <a:cs typeface="Malgun Gothic"/>
+                        </a:rPr>
+                        <a:t>0.143</a:t>
                       </a:r>
                     </a:p>
                   </a:txBody>
@@ -5218,42 +5305,13 @@
                     <a:bodyPr wrap="square"/>
                     <a:lstStyle/>
                     <a:p>
-                      <a:pPr algn="l">
-                        <a:lnSpc>
-                          <a:spcPct val="115000"/>
-                        </a:lnSpc>
-                      </a:pPr>
-                      <a:r>
-                        <a:rPr sz="950" b="1">
-                          <a:solidFill>
-                            <a:srgbClr val="16181D"/>
-                          </a:solidFill>
-                          <a:latin typeface="Malgun Gothic"/>
-                          <a:ea typeface="Malgun Gothic"/>
-                          <a:cs typeface="Malgun Gothic"/>
-                        </a:rPr>
-                        <a:t>A6000+2 / bf16</a:t>
-                      </a:r>
-                    </a:p>
-                  </a:txBody>
-                  <a:tcPr marL="82296" marR="82296" marT="41148" marB="41148" anchor="ctr">
-                    <a:solidFill>
-                      <a:srgbClr val="FFFFFF"/>
-                    </a:solidFill>
-                  </a:tcPr>
-                </a:tc>
-                <a:tc>
-                  <a:txBody>
-                    <a:bodyPr wrap="square"/>
-                    <a:lstStyle/>
-                    <a:p>
                       <a:pPr algn="r">
                         <a:lnSpc>
                           <a:spcPct val="115000"/>
                         </a:lnSpc>
                       </a:pPr>
                       <a:r>
-                        <a:rPr sz="1000" b="0">
+                        <a:rPr sz="950" b="0">
                           <a:solidFill>
                             <a:srgbClr val="565C66"/>
                           </a:solidFill>
@@ -5261,65 +5319,7 @@
                           <a:ea typeface="Malgun Gothic"/>
                           <a:cs typeface="Malgun Gothic"/>
                         </a:rPr>
-                        <a:t>0.257</a:t>
-                      </a:r>
-                    </a:p>
-                  </a:txBody>
-                  <a:tcPr marL="82296" marR="82296" marT="41148" marB="41148" anchor="ctr">
-                    <a:solidFill>
-                      <a:srgbClr val="FFFFFF"/>
-                    </a:solidFill>
-                  </a:tcPr>
-                </a:tc>
-                <a:tc>
-                  <a:txBody>
-                    <a:bodyPr wrap="square"/>
-                    <a:lstStyle/>
-                    <a:p>
-                      <a:pPr algn="r">
-                        <a:lnSpc>
-                          <a:spcPct val="115000"/>
-                        </a:lnSpc>
-                      </a:pPr>
-                      <a:r>
-                        <a:rPr sz="1000" b="1">
-                          <a:solidFill>
-                            <a:srgbClr val="C1442A"/>
-                          </a:solidFill>
-                          <a:latin typeface="Malgun Gothic"/>
-                          <a:ea typeface="Malgun Gothic"/>
-                          <a:cs typeface="Malgun Gothic"/>
-                        </a:rPr>
-                        <a:t>0.143</a:t>
-                      </a:r>
-                    </a:p>
-                  </a:txBody>
-                  <a:tcPr marL="82296" marR="82296" marT="41148" marB="41148" anchor="ctr">
-                    <a:solidFill>
-                      <a:srgbClr val="FFFFFF"/>
-                    </a:solidFill>
-                  </a:tcPr>
-                </a:tc>
-                <a:tc>
-                  <a:txBody>
-                    <a:bodyPr wrap="square"/>
-                    <a:lstStyle/>
-                    <a:p>
-                      <a:pPr algn="ctr">
-                        <a:lnSpc>
-                          <a:spcPct val="115000"/>
-                        </a:lnSpc>
-                      </a:pPr>
-                      <a:r>
-                        <a:rPr sz="1000" b="0">
-                          <a:solidFill>
-                            <a:srgbClr val="565C66"/>
-                          </a:solidFill>
-                          <a:latin typeface="Malgun Gothic"/>
-                          <a:ea typeface="Malgun Gothic"/>
-                          <a:cs typeface="Malgun Gothic"/>
-                        </a:rPr>
-                        <a:t>5</a:t>
+                        <a:t>0.286</a:t>
                       </a:r>
                     </a:p>
                   </a:txBody>
@@ -5400,6 +5400,64 @@
                         </a:lnSpc>
                       </a:pPr>
                       <a:r>
+                        <a:rPr sz="950" b="0">
+                          <a:solidFill>
+                            <a:srgbClr val="565C66"/>
+                          </a:solidFill>
+                          <a:latin typeface="Malgun Gothic"/>
+                          <a:ea typeface="Malgun Gothic"/>
+                          <a:cs typeface="Malgun Gothic"/>
+                        </a:rPr>
+                        <a:t>(대조) 7B·8B bf16</a:t>
+                      </a:r>
+                    </a:p>
+                  </a:txBody>
+                  <a:tcPr marL="82296" marR="82296" marT="41148" marB="41148" anchor="ctr">
+                    <a:solidFill>
+                      <a:srgbClr val="F7F7F9"/>
+                    </a:solidFill>
+                  </a:tcPr>
+                </a:tc>
+                <a:tc>
+                  <a:txBody>
+                    <a:bodyPr wrap="square"/>
+                    <a:lstStyle/>
+                    <a:p>
+                      <a:pPr algn="l">
+                        <a:lnSpc>
+                          <a:spcPct val="115000"/>
+                        </a:lnSpc>
+                      </a:pPr>
+                      <a:r>
+                        <a:rPr sz="900" b="0">
+                          <a:solidFill>
+                            <a:srgbClr val="565C66"/>
+                          </a:solidFill>
+                          <a:latin typeface="Malgun Gothic"/>
+                          <a:ea typeface="Malgun Gothic"/>
+                          <a:cs typeface="Malgun Gothic"/>
+                        </a:rPr>
+                        <a:t>4090 / bf16</a:t>
+                      </a:r>
+                    </a:p>
+                  </a:txBody>
+                  <a:tcPr marL="82296" marR="82296" marT="41148" marB="41148" anchor="ctr">
+                    <a:solidFill>
+                      <a:srgbClr val="F7F7F9"/>
+                    </a:solidFill>
+                  </a:tcPr>
+                </a:tc>
+                <a:tc>
+                  <a:txBody>
+                    <a:bodyPr wrap="square"/>
+                    <a:lstStyle/>
+                    <a:p>
+                      <a:pPr algn="r">
+                        <a:lnSpc>
+                          <a:spcPct val="115000"/>
+                        </a:lnSpc>
+                      </a:pPr>
+                      <a:r>
                         <a:rPr sz="1000" b="0">
                           <a:solidFill>
                             <a:srgbClr val="565C66"/>
@@ -5408,7 +5466,7 @@
                           <a:ea typeface="Malgun Gothic"/>
                           <a:cs typeface="Malgun Gothic"/>
                         </a:rPr>
-                        <a:t>(대조) 7B·8B bf16</a:t>
+                        <a:t>~0.18</a:t>
                       </a:r>
                     </a:p>
                   </a:txBody>
@@ -5423,7 +5481,36 @@
                     <a:bodyPr wrap="square"/>
                     <a:lstStyle/>
                     <a:p>
-                      <a:pPr algn="l">
+                      <a:pPr algn="r">
+                        <a:lnSpc>
+                          <a:spcPct val="115000"/>
+                        </a:lnSpc>
+                      </a:pPr>
+                      <a:r>
+                        <a:rPr sz="1000" b="1">
+                          <a:solidFill>
+                            <a:srgbClr val="2F6FCE"/>
+                          </a:solidFill>
+                          <a:latin typeface="Malgun Gothic"/>
+                          <a:ea typeface="Malgun Gothic"/>
+                          <a:cs typeface="Malgun Gothic"/>
+                        </a:rPr>
+                        <a:t>0.000</a:t>
+                      </a:r>
+                    </a:p>
+                  </a:txBody>
+                  <a:tcPr marL="82296" marR="82296" marT="41148" marB="41148" anchor="ctr">
+                    <a:solidFill>
+                      <a:srgbClr val="F7F7F9"/>
+                    </a:solidFill>
+                  </a:tcPr>
+                </a:tc>
+                <a:tc>
+                  <a:txBody>
+                    <a:bodyPr wrap="square"/>
+                    <a:lstStyle/>
+                    <a:p>
+                      <a:pPr algn="r">
                         <a:lnSpc>
                           <a:spcPct val="115000"/>
                         </a:lnSpc>
@@ -5437,7 +5524,7 @@
                           <a:ea typeface="Malgun Gothic"/>
                           <a:cs typeface="Malgun Gothic"/>
                         </a:rPr>
-                        <a:t>4090 / bf16</a:t>
+                        <a:t>0.31</a:t>
                       </a:r>
                     </a:p>
                   </a:txBody>
@@ -5452,7 +5539,36 @@
                     <a:bodyPr wrap="square"/>
                     <a:lstStyle/>
                     <a:p>
-                      <a:pPr algn="r">
+                      <a:pPr algn="ctr">
+                        <a:lnSpc>
+                          <a:spcPct val="115000"/>
+                        </a:lnSpc>
+                      </a:pPr>
+                      <a:r>
+                        <a:rPr sz="1000" b="1">
+                          <a:solidFill>
+                            <a:srgbClr val="2F6FCE"/>
+                          </a:solidFill>
+                          <a:latin typeface="Malgun Gothic"/>
+                          <a:ea typeface="Malgun Gothic"/>
+                          <a:cs typeface="Malgun Gothic"/>
+                        </a:rPr>
+                        <a:t>0</a:t>
+                      </a:r>
+                    </a:p>
+                  </a:txBody>
+                  <a:tcPr marL="82296" marR="82296" marT="41148" marB="41148" anchor="ctr">
+                    <a:solidFill>
+                      <a:srgbClr val="F7F7F9"/>
+                    </a:solidFill>
+                  </a:tcPr>
+                </a:tc>
+                <a:tc>
+                  <a:txBody>
+                    <a:bodyPr wrap="square"/>
+                    <a:lstStyle/>
+                    <a:p>
+                      <a:pPr algn="ctr">
                         <a:lnSpc>
                           <a:spcPct val="115000"/>
                         </a:lnSpc>
@@ -5466,123 +5582,7 @@
                           <a:ea typeface="Malgun Gothic"/>
                           <a:cs typeface="Malgun Gothic"/>
                         </a:rPr>
-                        <a:t>~0.18</a:t>
-                      </a:r>
-                    </a:p>
-                  </a:txBody>
-                  <a:tcPr marL="82296" marR="82296" marT="41148" marB="41148" anchor="ctr">
-                    <a:solidFill>
-                      <a:srgbClr val="F7F7F9"/>
-                    </a:solidFill>
-                  </a:tcPr>
-                </a:tc>
-                <a:tc>
-                  <a:txBody>
-                    <a:bodyPr wrap="square"/>
-                    <a:lstStyle/>
-                    <a:p>
-                      <a:pPr algn="r">
-                        <a:lnSpc>
-                          <a:spcPct val="115000"/>
-                        </a:lnSpc>
-                      </a:pPr>
-                      <a:r>
-                        <a:rPr sz="1000" b="1">
-                          <a:solidFill>
-                            <a:srgbClr val="2F6FCE"/>
-                          </a:solidFill>
-                          <a:latin typeface="Malgun Gothic"/>
-                          <a:ea typeface="Malgun Gothic"/>
-                          <a:cs typeface="Malgun Gothic"/>
-                        </a:rPr>
-                        <a:t>0.000</a:t>
-                      </a:r>
-                    </a:p>
-                  </a:txBody>
-                  <a:tcPr marL="82296" marR="82296" marT="41148" marB="41148" anchor="ctr">
-                    <a:solidFill>
-                      <a:srgbClr val="F7F7F9"/>
-                    </a:solidFill>
-                  </a:tcPr>
-                </a:tc>
-                <a:tc>
-                  <a:txBody>
-                    <a:bodyPr wrap="square"/>
-                    <a:lstStyle/>
-                    <a:p>
-                      <a:pPr algn="ctr">
-                        <a:lnSpc>
-                          <a:spcPct val="115000"/>
-                        </a:lnSpc>
-                      </a:pPr>
-                      <a:r>
-                        <a:rPr sz="1000" b="0">
-                          <a:solidFill>
-                            <a:srgbClr val="565C66"/>
-                          </a:solidFill>
-                          <a:latin typeface="Malgun Gothic"/>
-                          <a:ea typeface="Malgun Gothic"/>
-                          <a:cs typeface="Malgun Gothic"/>
-                        </a:rPr>
-                        <a:t>전량</a:t>
-                      </a:r>
-                    </a:p>
-                  </a:txBody>
-                  <a:tcPr marL="82296" marR="82296" marT="41148" marB="41148" anchor="ctr">
-                    <a:solidFill>
-                      <a:srgbClr val="F7F7F9"/>
-                    </a:solidFill>
-                  </a:tcPr>
-                </a:tc>
-                <a:tc>
-                  <a:txBody>
-                    <a:bodyPr wrap="square"/>
-                    <a:lstStyle/>
-                    <a:p>
-                      <a:pPr algn="ctr">
-                        <a:lnSpc>
-                          <a:spcPct val="115000"/>
-                        </a:lnSpc>
-                      </a:pPr>
-                      <a:r>
-                        <a:rPr sz="1000" b="1">
-                          <a:solidFill>
-                            <a:srgbClr val="2F6FCE"/>
-                          </a:solidFill>
-                          <a:latin typeface="Malgun Gothic"/>
-                          <a:ea typeface="Malgun Gothic"/>
-                          <a:cs typeface="Malgun Gothic"/>
-                        </a:rPr>
                         <a:t>0</a:t>
-                      </a:r>
-                    </a:p>
-                  </a:txBody>
-                  <a:tcPr marL="82296" marR="82296" marT="41148" marB="41148" anchor="ctr">
-                    <a:solidFill>
-                      <a:srgbClr val="F7F7F9"/>
-                    </a:solidFill>
-                  </a:tcPr>
-                </a:tc>
-                <a:tc>
-                  <a:txBody>
-                    <a:bodyPr wrap="square"/>
-                    <a:lstStyle/>
-                    <a:p>
-                      <a:pPr algn="ctr">
-                        <a:lnSpc>
-                          <a:spcPct val="115000"/>
-                        </a:lnSpc>
-                      </a:pPr>
-                      <a:r>
-                        <a:rPr sz="1000" b="0">
-                          <a:solidFill>
-                            <a:srgbClr val="565C66"/>
-                          </a:solidFill>
-                          <a:latin typeface="Malgun Gothic"/>
-                          <a:ea typeface="Malgun Gothic"/>
-                          <a:cs typeface="Malgun Gothic"/>
-                        </a:rPr>
-                        <a:t>—</a:t>
                       </a:r>
                     </a:p>
                   </a:txBody>
@@ -5606,7 +5606,7 @@
         <p:spPr>
           <a:xfrm>
             <a:off x="640080" y="3931920"/>
-            <a:ext cx="10908792" cy="1874519"/>
+            <a:ext cx="10908792" cy="2148840"/>
           </a:xfrm>
           <a:prstGeom prst="roundRect">
             <a:avLst>
@@ -5649,8 +5649,8 @@
         </p:nvSpPr>
         <p:spPr>
           <a:xfrm>
-            <a:off x="914400" y="4114800"/>
-            <a:ext cx="10360152" cy="1554480"/>
+            <a:off x="914400" y="4096512"/>
+            <a:ext cx="10360152" cy="1828800"/>
           </a:xfrm>
           <a:prstGeom prst="rect">
             <a:avLst/>
@@ -5669,59 +5669,48 @@
               </a:lnSpc>
             </a:pPr>
             <a:r>
-              <a:rPr sz="1200" b="0">
-                <a:solidFill>
-                  <a:srgbClr val="565C66"/>
+              <a:rPr sz="1150" b="1">
+                <a:solidFill>
+                  <a:srgbClr val="2F6FCE"/>
                 </a:solidFill>
                 <a:latin typeface="Malgun Gothic"/>
                 <a:ea typeface="Malgun Gothic"/>
                 <a:cs typeface="Malgun Gothic"/>
               </a:rPr>
-              <a:t>두 nf4dq 실행(둘 다 slack 풀 35쌍 전수) 비교 시 </a:t>
-            </a:r>
-            <a:r>
-              <a:rPr sz="1200" b="1">
-                <a:solidFill>
-                  <a:srgbClr val="C1442A"/>
+              <a:t>4bit는 GPU 고정 시 결정론적</a:t>
+            </a:r>
+            <a:r>
+              <a:rPr sz="1150" b="0">
+                <a:solidFill>
+                  <a:srgbClr val="565C66"/>
                 </a:solidFill>
                 <a:latin typeface="Malgun Gothic"/>
                 <a:ea typeface="Malgun Gothic"/>
                 <a:cs typeface="Malgun Gothic"/>
               </a:rPr>
-              <a:t>slack 12/35쌍(34%) 불일치, 그중 8쌍이 baseline 차이</a:t>
-            </a:r>
-            <a:r>
-              <a:rPr sz="1200" b="0">
-                <a:solidFill>
-                  <a:srgbClr val="565C66"/>
+              <a:t> (7B와 동일) — A6000 3회·Blackwell 5회 각각 slack 35쌍 전부 일치. 이전에 본 "nf4dq 실행 간 12/35 불일치"는 run-to-run 노이즈가 아니라 </a:t>
+            </a:r>
+            <a:r>
+              <a:rPr sz="1150" b="1">
+                <a:solidFill>
+                  <a:srgbClr val="C1442A"/>
                 </a:solidFill>
                 <a:latin typeface="Malgun Gothic"/>
                 <a:ea typeface="Malgun Gothic"/>
                 <a:cs typeface="Malgun Gothic"/>
               </a:rPr>
-              <a:t> (user_task_0·2가 k0 붕괴) → </a:t>
-            </a:r>
-            <a:r>
-              <a:rPr sz="1200" b="1">
-                <a:solidFill>
-                  <a:srgbClr val="C1442A"/>
+              <a:t>A6000 ↔ Blackwell 아키텍처 차이</a:t>
+            </a:r>
+            <a:r>
+              <a:rPr sz="1150" b="0">
+                <a:solidFill>
+                  <a:srgbClr val="565C66"/>
                 </a:solidFill>
                 <a:latin typeface="Malgun Gothic"/>
                 <a:ea typeface="Malgun Gothic"/>
                 <a:cs typeface="Malgun Gothic"/>
               </a:rPr>
-              <a:t>32B-4bit 평가는 run-to-run 비결정적</a:t>
-            </a:r>
-            <a:r>
-              <a:rPr sz="1200" b="0">
-                <a:solidFill>
-                  <a:srgbClr val="565C66"/>
-                </a:solidFill>
-                <a:latin typeface="Malgun Gothic"/>
-                <a:ea typeface="Malgun Gothic"/>
-                <a:cs typeface="Malgun Gothic"/>
-              </a:rPr>
-              <a:t> — 이 경로로는 스케일 판정 불가.</a:t>
+              <a:t>.</a:t>
             </a:r>
           </a:p>
           <a:p>
@@ -5730,22 +5719,22 @@
                 <a:spcPct val="125000"/>
               </a:lnSpc>
               <a:spcBef>
-                <a:spcPts val="800"/>
+                <a:spcPts val="700"/>
               </a:spcBef>
             </a:pPr>
             <a:r>
-              <a:rPr sz="1200" b="1">
-                <a:solidFill>
-                  <a:srgbClr val="2F6FCE"/>
+              <a:rPr sz="1150" b="1">
+                <a:solidFill>
+                  <a:srgbClr val="C1442A"/>
                 </a:solidFill>
                 <a:latin typeface="Malgun Gothic"/>
                 <a:ea typeface="Malgun Gothic"/>
                 <a:cs typeface="Malgun Gothic"/>
               </a:rPr>
-              <a:t>bf16으로 우회</a:t>
-            </a:r>
-            <a:r>
-              <a:rPr sz="1200" b="0">
+              <a:t>원인: Blackwell sm_120의 bnb nf4 커널이 32B 손상</a:t>
+            </a:r>
+            <a:r>
+              <a:rPr sz="1150" b="0">
                 <a:solidFill>
                   <a:srgbClr val="565C66"/>
                 </a:solidFill>
@@ -5753,10 +5742,10 @@
                 <a:ea typeface="Malgun Gothic"/>
                 <a:cs typeface="Malgun Gothic"/>
               </a:rPr>
-              <a:t>: 완주율 100%·결정론적인데도 kN ASR 0.143(≠0) + backfire 1 — 7B·8B bf16(전량 억제·backfire 0)과 질적으로 다름 → </a:t>
-            </a:r>
-            <a:r>
-              <a:rPr sz="1200" b="1">
+              <a:t> — slack k0_util 0.286(=bf16) → 0.09 붕괴. → </a:t>
+            </a:r>
+            <a:r>
+              <a:rPr sz="1150" b="1">
                 <a:solidFill>
                   <a:srgbClr val="16181D"/>
                 </a:solidFill>
@@ -5764,7 +5753,39 @@
                 <a:ea typeface="Malgun Gothic"/>
                 <a:cs typeface="Malgun Gothic"/>
               </a:rPr>
-              <a:t>fp4와 무관한 스케일 기여 확인.</a:t>
+              <a:t>A6000 nf4dq가 신뢰 가능한 4bit 실행.</a:t>
+            </a:r>
+          </a:p>
+          <a:p>
+            <a:pPr algn="l">
+              <a:lnSpc>
+                <a:spcPct val="125000"/>
+              </a:lnSpc>
+              <a:spcBef>
+                <a:spcPts val="700"/>
+              </a:spcBef>
+            </a:pPr>
+            <a:r>
+              <a:rPr sz="1150" b="1">
+                <a:solidFill>
+                  <a:srgbClr val="2F6FCE"/>
+                </a:solidFill>
+                <a:latin typeface="Malgun Gothic"/>
+                <a:ea typeface="Malgun Gothic"/>
+                <a:cs typeface="Malgun Gothic"/>
+              </a:rPr>
+              <a:t>스케일 효과 확정</a:t>
+            </a:r>
+            <a:r>
+              <a:rPr sz="1150" b="0">
+                <a:solidFill>
+                  <a:srgbClr val="565C66"/>
+                </a:solidFill>
+                <a:latin typeface="Malgun Gothic"/>
+                <a:ea typeface="Malgun Gothic"/>
+                <a:cs typeface="Malgun Gothic"/>
+              </a:rPr>
+              <a:t>: bf16(양자화 배제)에서 kN 0.143(≠0) + backfire 1 vs 7B·8B bf16 전량 억제. A6000에서 nf4dq·bf16 둘 다 8B에 못 미침.</a:t>
             </a:r>
           </a:p>
         </p:txBody>
@@ -5922,7 +5943,7 @@
         <p:spPr>
           <a:xfrm>
             <a:off x="640080" y="1691640"/>
-            <a:ext cx="10908792" cy="2331720"/>
+            <a:ext cx="10908792" cy="2606040"/>
           </a:xfrm>
           <a:prstGeom prst="roundRect">
             <a:avLst>
@@ -5966,7 +5987,7 @@
         <p:spPr>
           <a:xfrm>
             <a:off x="914400" y="1856232"/>
-            <a:ext cx="10360152" cy="2103120"/>
+            <a:ext cx="10360152" cy="2377440"/>
           </a:xfrm>
           <a:prstGeom prst="rect">
             <a:avLst/>
@@ -6122,7 +6143,7 @@
                 <a:ea typeface="Malgun Gothic"/>
                 <a:cs typeface="Malgun Gothic"/>
               </a:rPr>
-              <a:t> — fp4 아티팩트 확정(nf4+dq로 해소·기본값 교체). 32B 스케일 효과 약하게 확정 — bf16 단독에서도 slack knockout 불완전 + backfire 1.</a:t>
+              <a:t> — fp4 아티팩트 확정(nf4+dq로 해소·기본값 교체). 32B 스케일 효과 약하게 확정 — bf16 단독에서도 slack knockout 불완전 + backfire 1. 4bit는 GPU 고정 시 결정론적 (이전 "비결정성"은 Blackwell 커널이 32B 손상시킨 것, A6000은 bf16과 일치).</a:t>
             </a:r>
           </a:p>
           <a:p>
@@ -6221,8 +6242,8 @@
         </p:nvSpPr>
         <p:spPr>
           <a:xfrm>
-            <a:off x="640080" y="4206240"/>
-            <a:ext cx="10908792" cy="1965960"/>
+            <a:off x="640080" y="4526280"/>
+            <a:ext cx="10908792" cy="1554480"/>
           </a:xfrm>
           <a:prstGeom prst="roundRect">
             <a:avLst>
@@ -6265,8 +6286,8 @@
         </p:nvSpPr>
         <p:spPr>
           <a:xfrm>
-            <a:off x="914400" y="4370832"/>
-            <a:ext cx="10360152" cy="1691640"/>
+            <a:off x="914400" y="4690872"/>
+            <a:ext cx="10360152" cy="1280160"/>
           </a:xfrm>
           <a:prstGeom prst="rect">
             <a:avLst/>
@@ -6380,49 +6401,6 @@
                 <a:cs typeface="Malgun Gothic"/>
               </a:rPr>
               <a:t> — injection_task 2/4는 near-unwinnable → AgentDojo 외 벤치마크/자체 시나리오로 다단계 knockout 효과 측정.</a:t>
-            </a:r>
-          </a:p>
-          <a:p>
-            <a:pPr algn="l">
-              <a:lnSpc>
-                <a:spcPct val="120000"/>
-              </a:lnSpc>
-              <a:spcBef>
-                <a:spcPts val="500"/>
-              </a:spcBef>
-            </a:pPr>
-            <a:r>
-              <a:rPr sz="1050" b="1">
-                <a:solidFill>
-                  <a:srgbClr val="C06A1F"/>
-                </a:solidFill>
-                <a:latin typeface="Malgun Gothic"/>
-                <a:ea typeface="Malgun Gothic"/>
-                <a:cs typeface="Malgun Gothic"/>
-              </a:rPr>
-              <a:t>·  </a:t>
-            </a:r>
-            <a:r>
-              <a:rPr sz="1050" b="1">
-                <a:solidFill>
-                  <a:srgbClr val="16181D"/>
-                </a:solidFill>
-                <a:latin typeface="Malgun Gothic"/>
-                <a:ea typeface="Malgun Gothic"/>
-                <a:cs typeface="Malgun Gothic"/>
-              </a:rPr>
-              <a:t>32B-4bit 비결정성 규명</a:t>
-            </a:r>
-            <a:r>
-              <a:rPr sz="1050" b="0">
-                <a:solidFill>
-                  <a:srgbClr val="565C66"/>
-                </a:solidFill>
-                <a:latin typeface="Malgun Gothic"/>
-                <a:ea typeface="Malgun Gothic"/>
-                <a:cs typeface="Malgun Gothic"/>
-              </a:rPr>
-              <a:t> — GPU 고정 시 결정론적인지 (진행 중: Blackwell 커널이 모델 손상, A6000은 bf16과 일치).</a:t>
             </a:r>
           </a:p>
           <a:p>

</xml_diff>

<commit_message>
docs(4th): S11 표에 k0/kN utility 열 추가 + 대조행 7B·Llama-8B 분리·실수치
slack held-out 35쌍 기준으로 k0_sec/kN_sec/k0_util/kN_util/backfire/persist 6열.
대조를 "7B·8B ~근사"에서 7B bf16(0.171→0.000)·Llama-8B bf16(0.200→0.000) 실측 2행으로.
Blackwell 열화 수치 0.09→0.086 통일. script + build_deck_4th.py + pptx.

Co-Authored-By: Claude Sonnet 5 <noreply@anthropic.com>
Claude-Session: https://claude.ai/code/session_01V7E9vi4ameJCetACyCoxpn
</commit_message>
<xml_diff>
--- a/docs/presentation/IPI_Head_Separation_PoC_4th [26-09-XX].pptx
+++ b/docs/presentation/IPI_Head_Separation_PoC_4th [26-09-XX].pptx
@@ -4541,17 +4541,58 @@
           </a:p>
         </p:txBody>
       </p:sp>
+      <p:sp>
+        <p:nvSpPr>
+          <p:cNvPr id="5" name="TextBox 4"/>
+          <p:cNvSpPr txBox="1"/>
+          <p:nvPr/>
+        </p:nvSpPr>
+        <p:spPr>
+          <a:xfrm>
+            <a:off x="640080" y="1618488"/>
+            <a:ext cx="10908792" cy="274320"/>
+          </a:xfrm>
+          <a:prstGeom prst="rect">
+            <a:avLst/>
+          </a:prstGeom>
+          <a:noFill/>
+        </p:spPr>
+        <p:txBody>
+          <a:bodyPr wrap="square" lIns="0" rIns="0" tIns="0" bIns="0">
+            <a:spAutoFit/>
+          </a:bodyPr>
+          <a:lstStyle/>
+          <a:p>
+            <a:pPr algn="l">
+              <a:lnSpc>
+                <a:spcPct val="125000"/>
+              </a:lnSpc>
+            </a:pPr>
+            <a:r>
+              <a:rPr sz="1000" b="0">
+                <a:solidFill>
+                  <a:srgbClr val="8B9099"/>
+                </a:solidFill>
+                <a:latin typeface="Malgun Gothic"/>
+                <a:ea typeface="Malgun Gothic"/>
+                <a:cs typeface="Malgun Gothic"/>
+              </a:rPr>
+              <a:t>모든 수치는 slack held-out 35쌍 기준</a:t>
+            </a:r>
+          </a:p>
+        </p:txBody>
+      </p:sp>
       <p:graphicFrame>
         <p:nvGraphicFramePr>
-          <p:cNvPr id="5" name="Table 4"/>
+          <p:cNvPr id="6" name="Table 5"/>
           <p:cNvGraphicFramePr>
             <a:graphicFrameLocks noGrp="1"/>
           </p:cNvGraphicFramePr>
           <p:nvPr/>
         </p:nvGraphicFramePr>
         <p:xfrm>
-          <a:off x="640080" y="1691640"/>
-          <a:ext cx="10908790" cy="2048256"/>
+          <a:off x="640080" y="1947672"/>
+          <a:ext cx="10908787" cy="2359152"/>
         </p:xfrm>
         <a:graphic>
           <a:graphicData uri="http://schemas.openxmlformats.org/drawingml/2006/table">
@@ -4560,15 +4601,16 @@
                 <a:tableStyleId>{5C22544A-7EE6-4342-B048-85BDC9FD1C3A}</a:tableStyleId>
               </a:tblPr>
               <a:tblGrid>
-                <a:gridCol w="2473139"/>
-                <a:gridCol w="2742936"/>
-                <a:gridCol w="1124154"/>
-                <a:gridCol w="1124154"/>
-                <a:gridCol w="1393951"/>
-                <a:gridCol w="1034221"/>
-                <a:gridCol w="1016235"/>
+                <a:gridCol w="2373540"/>
+                <a:gridCol w="2800777"/>
+                <a:gridCol w="1091828"/>
+                <a:gridCol w="1091828"/>
+                <a:gridCol w="1091828"/>
+                <a:gridCol w="1091828"/>
+                <a:gridCol w="683579"/>
+                <a:gridCol w="683579"/>
               </a:tblGrid>
-              <a:tr h="365760">
+              <a:tr h="347472">
                 <a:tc>
                   <a:txBody>
                     <a:bodyPr wrap="square"/>
@@ -4580,6 +4622,64 @@
                         </a:lnSpc>
                       </a:pPr>
                       <a:r>
+                        <a:rPr sz="900" b="1">
+                          <a:solidFill>
+                            <a:srgbClr val="8B9099"/>
+                          </a:solidFill>
+                          <a:latin typeface="Malgun Gothic"/>
+                          <a:ea typeface="Malgun Gothic"/>
+                          <a:cs typeface="Malgun Gothic"/>
+                        </a:rPr>
+                        <a:t>실행</a:t>
+                      </a:r>
+                    </a:p>
+                  </a:txBody>
+                  <a:tcPr marL="82296" marR="82296" marT="41148" marB="41148" anchor="ctr">
+                    <a:solidFill>
+                      <a:srgbClr val="E9EAED"/>
+                    </a:solidFill>
+                  </a:tcPr>
+                </a:tc>
+                <a:tc>
+                  <a:txBody>
+                    <a:bodyPr wrap="square"/>
+                    <a:lstStyle/>
+                    <a:p>
+                      <a:pPr algn="l">
+                        <a:lnSpc>
+                          <a:spcPct val="100000"/>
+                        </a:lnSpc>
+                      </a:pPr>
+                      <a:r>
+                        <a:rPr sz="850" b="1">
+                          <a:solidFill>
+                            <a:srgbClr val="8B9099"/>
+                          </a:solidFill>
+                          <a:latin typeface="Malgun Gothic"/>
+                          <a:ea typeface="Malgun Gothic"/>
+                          <a:cs typeface="Malgun Gothic"/>
+                        </a:rPr>
+                        <a:t>GPU / quant</a:t>
+                      </a:r>
+                    </a:p>
+                  </a:txBody>
+                  <a:tcPr marL="82296" marR="82296" marT="41148" marB="41148" anchor="ctr">
+                    <a:solidFill>
+                      <a:srgbClr val="E9EAED"/>
+                    </a:solidFill>
+                  </a:tcPr>
+                </a:tc>
+                <a:tc>
+                  <a:txBody>
+                    <a:bodyPr wrap="square"/>
+                    <a:lstStyle/>
+                    <a:p>
+                      <a:pPr algn="r">
+                        <a:lnSpc>
+                          <a:spcPct val="100000"/>
+                        </a:lnSpc>
+                      </a:pPr>
+                      <a:r>
                         <a:rPr sz="950" b="1">
                           <a:solidFill>
                             <a:srgbClr val="8B9099"/>
@@ -4588,7 +4688,7 @@
                           <a:ea typeface="Malgun Gothic"/>
                           <a:cs typeface="Malgun Gothic"/>
                         </a:rPr>
-                        <a:t>실행</a:t>
+                        <a:t>k0_sec</a:t>
                       </a:r>
                     </a:p>
                   </a:txBody>
@@ -4603,27 +4703,671 @@
                     <a:bodyPr wrap="square"/>
                     <a:lstStyle/>
                     <a:p>
+                      <a:pPr algn="r">
+                        <a:lnSpc>
+                          <a:spcPct val="100000"/>
+                        </a:lnSpc>
+                      </a:pPr>
+                      <a:r>
+                        <a:rPr sz="950" b="1">
+                          <a:solidFill>
+                            <a:srgbClr val="8B9099"/>
+                          </a:solidFill>
+                          <a:latin typeface="Malgun Gothic"/>
+                          <a:ea typeface="Malgun Gothic"/>
+                          <a:cs typeface="Malgun Gothic"/>
+                        </a:rPr>
+                        <a:t>kN_sec</a:t>
+                      </a:r>
+                    </a:p>
+                  </a:txBody>
+                  <a:tcPr marL="82296" marR="82296" marT="41148" marB="41148" anchor="ctr">
+                    <a:solidFill>
+                      <a:srgbClr val="E9EAED"/>
+                    </a:solidFill>
+                  </a:tcPr>
+                </a:tc>
+                <a:tc>
+                  <a:txBody>
+                    <a:bodyPr wrap="square"/>
+                    <a:lstStyle/>
+                    <a:p>
+                      <a:pPr algn="r">
+                        <a:lnSpc>
+                          <a:spcPct val="100000"/>
+                        </a:lnSpc>
+                      </a:pPr>
+                      <a:r>
+                        <a:rPr sz="950" b="1">
+                          <a:solidFill>
+                            <a:srgbClr val="8B9099"/>
+                          </a:solidFill>
+                          <a:latin typeface="Malgun Gothic"/>
+                          <a:ea typeface="Malgun Gothic"/>
+                          <a:cs typeface="Malgun Gothic"/>
+                        </a:rPr>
+                        <a:t>k0_util</a:t>
+                      </a:r>
+                    </a:p>
+                  </a:txBody>
+                  <a:tcPr marL="82296" marR="82296" marT="41148" marB="41148" anchor="ctr">
+                    <a:solidFill>
+                      <a:srgbClr val="E9EAED"/>
+                    </a:solidFill>
+                  </a:tcPr>
+                </a:tc>
+                <a:tc>
+                  <a:txBody>
+                    <a:bodyPr wrap="square"/>
+                    <a:lstStyle/>
+                    <a:p>
+                      <a:pPr algn="r">
+                        <a:lnSpc>
+                          <a:spcPct val="100000"/>
+                        </a:lnSpc>
+                      </a:pPr>
+                      <a:r>
+                        <a:rPr sz="950" b="1">
+                          <a:solidFill>
+                            <a:srgbClr val="8B9099"/>
+                          </a:solidFill>
+                          <a:latin typeface="Malgun Gothic"/>
+                          <a:ea typeface="Malgun Gothic"/>
+                          <a:cs typeface="Malgun Gothic"/>
+                        </a:rPr>
+                        <a:t>kN_util</a:t>
+                      </a:r>
+                    </a:p>
+                  </a:txBody>
+                  <a:tcPr marL="82296" marR="82296" marT="41148" marB="41148" anchor="ctr">
+                    <a:solidFill>
+                      <a:srgbClr val="E9EAED"/>
+                    </a:solidFill>
+                  </a:tcPr>
+                </a:tc>
+                <a:tc>
+                  <a:txBody>
+                    <a:bodyPr wrap="square"/>
+                    <a:lstStyle/>
+                    <a:p>
+                      <a:pPr algn="ctr">
+                        <a:lnSpc>
+                          <a:spcPct val="100000"/>
+                        </a:lnSpc>
+                      </a:pPr>
+                      <a:r>
+                        <a:rPr sz="950" b="1">
+                          <a:solidFill>
+                            <a:srgbClr val="8B9099"/>
+                          </a:solidFill>
+                          <a:latin typeface="Malgun Gothic"/>
+                          <a:ea typeface="Malgun Gothic"/>
+                          <a:cs typeface="Malgun Gothic"/>
+                        </a:rPr>
+                        <a:t>bf</a:t>
+                      </a:r>
+                    </a:p>
+                  </a:txBody>
+                  <a:tcPr marL="82296" marR="82296" marT="41148" marB="41148" anchor="ctr">
+                    <a:solidFill>
+                      <a:srgbClr val="E9EAED"/>
+                    </a:solidFill>
+                  </a:tcPr>
+                </a:tc>
+                <a:tc>
+                  <a:txBody>
+                    <a:bodyPr wrap="square"/>
+                    <a:lstStyle/>
+                    <a:p>
+                      <a:pPr algn="ctr">
+                        <a:lnSpc>
+                          <a:spcPct val="100000"/>
+                        </a:lnSpc>
+                      </a:pPr>
+                      <a:r>
+                        <a:rPr sz="950" b="1">
+                          <a:solidFill>
+                            <a:srgbClr val="8B9099"/>
+                          </a:solidFill>
+                          <a:latin typeface="Malgun Gothic"/>
+                          <a:ea typeface="Malgun Gothic"/>
+                          <a:cs typeface="Malgun Gothic"/>
+                        </a:rPr>
+                        <a:t>per</a:t>
+                      </a:r>
+                    </a:p>
+                  </a:txBody>
+                  <a:tcPr marL="82296" marR="82296" marT="41148" marB="41148" anchor="ctr">
+                    <a:solidFill>
+                      <a:srgbClr val="E9EAED"/>
+                    </a:solidFill>
+                  </a:tcPr>
+                </a:tc>
+              </a:tr>
+              <a:tr h="402336">
+                <a:tc>
+                  <a:txBody>
+                    <a:bodyPr wrap="square"/>
+                    <a:lstStyle/>
+                    <a:p>
                       <a:pPr algn="l">
                         <a:lnSpc>
-                          <a:spcPct val="100000"/>
+                          <a:spcPct val="115000"/>
+                        </a:lnSpc>
+                      </a:pPr>
+                      <a:r>
+                        <a:rPr sz="900" b="0">
+                          <a:solidFill>
+                            <a:srgbClr val="565C66"/>
+                          </a:solidFill>
+                          <a:latin typeface="Malgun Gothic"/>
+                          <a:ea typeface="Malgun Gothic"/>
+                          <a:cs typeface="Malgun Gothic"/>
+                        </a:rPr>
+                        <a:t>32B nf4dq  (×3 동일)</a:t>
+                      </a:r>
+                    </a:p>
+                  </a:txBody>
+                  <a:tcPr marL="82296" marR="82296" marT="41148" marB="41148" anchor="ctr">
+                    <a:solidFill>
+                      <a:srgbClr val="FFFFFF"/>
+                    </a:solidFill>
+                  </a:tcPr>
+                </a:tc>
+                <a:tc>
+                  <a:txBody>
+                    <a:bodyPr wrap="square"/>
+                    <a:lstStyle/>
+                    <a:p>
+                      <a:pPr algn="l">
+                        <a:lnSpc>
+                          <a:spcPct val="115000"/>
+                        </a:lnSpc>
+                      </a:pPr>
+                      <a:r>
+                        <a:rPr sz="850" b="0">
+                          <a:solidFill>
+                            <a:srgbClr val="565C66"/>
+                          </a:solidFill>
+                          <a:latin typeface="Malgun Gothic"/>
+                          <a:ea typeface="Malgun Gothic"/>
+                          <a:cs typeface="Malgun Gothic"/>
+                        </a:rPr>
+                        <a:t>A6000 sm_86 / nf4dq</a:t>
+                      </a:r>
+                    </a:p>
+                  </a:txBody>
+                  <a:tcPr marL="82296" marR="82296" marT="41148" marB="41148" anchor="ctr">
+                    <a:solidFill>
+                      <a:srgbClr val="FFFFFF"/>
+                    </a:solidFill>
+                  </a:tcPr>
+                </a:tc>
+                <a:tc>
+                  <a:txBody>
+                    <a:bodyPr wrap="square"/>
+                    <a:lstStyle/>
+                    <a:p>
+                      <a:pPr algn="r">
+                        <a:lnSpc>
+                          <a:spcPct val="115000"/>
+                        </a:lnSpc>
+                      </a:pPr>
+                      <a:r>
+                        <a:rPr sz="950" b="0">
+                          <a:solidFill>
+                            <a:srgbClr val="565C66"/>
+                          </a:solidFill>
+                          <a:latin typeface="Malgun Gothic"/>
+                          <a:ea typeface="Malgun Gothic"/>
+                          <a:cs typeface="Malgun Gothic"/>
+                        </a:rPr>
+                        <a:t>0.229</a:t>
+                      </a:r>
+                    </a:p>
+                  </a:txBody>
+                  <a:tcPr marL="82296" marR="82296" marT="41148" marB="41148" anchor="ctr">
+                    <a:solidFill>
+                      <a:srgbClr val="FFFFFF"/>
+                    </a:solidFill>
+                  </a:tcPr>
+                </a:tc>
+                <a:tc>
+                  <a:txBody>
+                    <a:bodyPr wrap="square"/>
+                    <a:lstStyle/>
+                    <a:p>
+                      <a:pPr algn="r">
+                        <a:lnSpc>
+                          <a:spcPct val="115000"/>
+                        </a:lnSpc>
+                      </a:pPr>
+                      <a:r>
+                        <a:rPr sz="950" b="0">
+                          <a:solidFill>
+                            <a:srgbClr val="565C66"/>
+                          </a:solidFill>
+                          <a:latin typeface="Malgun Gothic"/>
+                          <a:ea typeface="Malgun Gothic"/>
+                          <a:cs typeface="Malgun Gothic"/>
+                        </a:rPr>
+                        <a:t>0.229</a:t>
+                      </a:r>
+                    </a:p>
+                  </a:txBody>
+                  <a:tcPr marL="82296" marR="82296" marT="41148" marB="41148" anchor="ctr">
+                    <a:solidFill>
+                      <a:srgbClr val="FFFFFF"/>
+                    </a:solidFill>
+                  </a:tcPr>
+                </a:tc>
+                <a:tc>
+                  <a:txBody>
+                    <a:bodyPr wrap="square"/>
+                    <a:lstStyle/>
+                    <a:p>
+                      <a:pPr algn="r">
+                        <a:lnSpc>
+                          <a:spcPct val="115000"/>
+                        </a:lnSpc>
+                      </a:pPr>
+                      <a:r>
+                        <a:rPr sz="950" b="0">
+                          <a:solidFill>
+                            <a:srgbClr val="565C66"/>
+                          </a:solidFill>
+                          <a:latin typeface="Malgun Gothic"/>
+                          <a:ea typeface="Malgun Gothic"/>
+                          <a:cs typeface="Malgun Gothic"/>
+                        </a:rPr>
+                        <a:t>0.286</a:t>
+                      </a:r>
+                    </a:p>
+                  </a:txBody>
+                  <a:tcPr marL="82296" marR="82296" marT="41148" marB="41148" anchor="ctr">
+                    <a:solidFill>
+                      <a:srgbClr val="FFFFFF"/>
+                    </a:solidFill>
+                  </a:tcPr>
+                </a:tc>
+                <a:tc>
+                  <a:txBody>
+                    <a:bodyPr wrap="square"/>
+                    <a:lstStyle/>
+                    <a:p>
+                      <a:pPr algn="r">
+                        <a:lnSpc>
+                          <a:spcPct val="115000"/>
+                        </a:lnSpc>
+                      </a:pPr>
+                      <a:r>
+                        <a:rPr sz="950" b="0">
+                          <a:solidFill>
+                            <a:srgbClr val="565C66"/>
+                          </a:solidFill>
+                          <a:latin typeface="Malgun Gothic"/>
+                          <a:ea typeface="Malgun Gothic"/>
+                          <a:cs typeface="Malgun Gothic"/>
+                        </a:rPr>
+                        <a:t>0.314</a:t>
+                      </a:r>
+                    </a:p>
+                  </a:txBody>
+                  <a:tcPr marL="82296" marR="82296" marT="41148" marB="41148" anchor="ctr">
+                    <a:solidFill>
+                      <a:srgbClr val="FFFFFF"/>
+                    </a:solidFill>
+                  </a:tcPr>
+                </a:tc>
+                <a:tc>
+                  <a:txBody>
+                    <a:bodyPr wrap="square"/>
+                    <a:lstStyle/>
+                    <a:p>
+                      <a:pPr algn="ctr">
+                        <a:lnSpc>
+                          <a:spcPct val="115000"/>
+                        </a:lnSpc>
+                      </a:pPr>
+                      <a:r>
+                        <a:rPr sz="950" b="0">
+                          <a:solidFill>
+                            <a:srgbClr val="565C66"/>
+                          </a:solidFill>
+                          <a:latin typeface="Malgun Gothic"/>
+                          <a:ea typeface="Malgun Gothic"/>
+                          <a:cs typeface="Malgun Gothic"/>
+                        </a:rPr>
+                        <a:t>2</a:t>
+                      </a:r>
+                    </a:p>
+                  </a:txBody>
+                  <a:tcPr marL="82296" marR="82296" marT="41148" marB="41148" anchor="ctr">
+                    <a:solidFill>
+                      <a:srgbClr val="FFFFFF"/>
+                    </a:solidFill>
+                  </a:tcPr>
+                </a:tc>
+                <a:tc>
+                  <a:txBody>
+                    <a:bodyPr wrap="square"/>
+                    <a:lstStyle/>
+                    <a:p>
+                      <a:pPr algn="ctr">
+                        <a:lnSpc>
+                          <a:spcPct val="115000"/>
+                        </a:lnSpc>
+                      </a:pPr>
+                      <a:r>
+                        <a:rPr sz="950" b="0">
+                          <a:solidFill>
+                            <a:srgbClr val="565C66"/>
+                          </a:solidFill>
+                          <a:latin typeface="Malgun Gothic"/>
+                          <a:ea typeface="Malgun Gothic"/>
+                          <a:cs typeface="Malgun Gothic"/>
+                        </a:rPr>
+                        <a:t>6</a:t>
+                      </a:r>
+                    </a:p>
+                  </a:txBody>
+                  <a:tcPr marL="82296" marR="82296" marT="41148" marB="41148" anchor="ctr">
+                    <a:solidFill>
+                      <a:srgbClr val="FFFFFF"/>
+                    </a:solidFill>
+                  </a:tcPr>
+                </a:tc>
+              </a:tr>
+              <a:tr h="402336">
+                <a:tc>
+                  <a:txBody>
+                    <a:bodyPr wrap="square"/>
+                    <a:lstStyle/>
+                    <a:p>
+                      <a:pPr algn="l">
+                        <a:lnSpc>
+                          <a:spcPct val="115000"/>
+                        </a:lnSpc>
+                      </a:pPr>
+                      <a:r>
+                        <a:rPr sz="900" b="0">
+                          <a:solidFill>
+                            <a:srgbClr val="565C66"/>
+                          </a:solidFill>
+                          <a:latin typeface="Malgun Gothic"/>
+                          <a:ea typeface="Malgun Gothic"/>
+                          <a:cs typeface="Malgun Gothic"/>
+                        </a:rPr>
+                        <a:t>32B nf4dq  (×5 동일)</a:t>
+                      </a:r>
+                    </a:p>
+                  </a:txBody>
+                  <a:tcPr marL="82296" marR="82296" marT="41148" marB="41148" anchor="ctr">
+                    <a:solidFill>
+                      <a:srgbClr val="F7F7F9"/>
+                    </a:solidFill>
+                  </a:tcPr>
+                </a:tc>
+                <a:tc>
+                  <a:txBody>
+                    <a:bodyPr wrap="square"/>
+                    <a:lstStyle/>
+                    <a:p>
+                      <a:pPr algn="l">
+                        <a:lnSpc>
+                          <a:spcPct val="115000"/>
+                        </a:lnSpc>
+                      </a:pPr>
+                      <a:r>
+                        <a:rPr sz="850" b="0">
+                          <a:solidFill>
+                            <a:srgbClr val="565C66"/>
+                          </a:solidFill>
+                          <a:latin typeface="Malgun Gothic"/>
+                          <a:ea typeface="Malgun Gothic"/>
+                          <a:cs typeface="Malgun Gothic"/>
+                        </a:rPr>
+                        <a:t>Blackwell sm_120 / nf4dq</a:t>
+                      </a:r>
+                    </a:p>
+                  </a:txBody>
+                  <a:tcPr marL="82296" marR="82296" marT="41148" marB="41148" anchor="ctr">
+                    <a:solidFill>
+                      <a:srgbClr val="F7F7F9"/>
+                    </a:solidFill>
+                  </a:tcPr>
+                </a:tc>
+                <a:tc>
+                  <a:txBody>
+                    <a:bodyPr wrap="square"/>
+                    <a:lstStyle/>
+                    <a:p>
+                      <a:pPr algn="r">
+                        <a:lnSpc>
+                          <a:spcPct val="115000"/>
+                        </a:lnSpc>
+                      </a:pPr>
+                      <a:r>
+                        <a:rPr sz="950" b="0">
+                          <a:solidFill>
+                            <a:srgbClr val="565C66"/>
+                          </a:solidFill>
+                          <a:latin typeface="Malgun Gothic"/>
+                          <a:ea typeface="Malgun Gothic"/>
+                          <a:cs typeface="Malgun Gothic"/>
+                        </a:rPr>
+                        <a:t>0.171</a:t>
+                      </a:r>
+                    </a:p>
+                  </a:txBody>
+                  <a:tcPr marL="82296" marR="82296" marT="41148" marB="41148" anchor="ctr">
+                    <a:solidFill>
+                      <a:srgbClr val="F7F7F9"/>
+                    </a:solidFill>
+                  </a:tcPr>
+                </a:tc>
+                <a:tc>
+                  <a:txBody>
+                    <a:bodyPr wrap="square"/>
+                    <a:lstStyle/>
+                    <a:p>
+                      <a:pPr algn="r">
+                        <a:lnSpc>
+                          <a:spcPct val="115000"/>
+                        </a:lnSpc>
+                      </a:pPr>
+                      <a:r>
+                        <a:rPr sz="950" b="0">
+                          <a:solidFill>
+                            <a:srgbClr val="565C66"/>
+                          </a:solidFill>
+                          <a:latin typeface="Malgun Gothic"/>
+                          <a:ea typeface="Malgun Gothic"/>
+                          <a:cs typeface="Malgun Gothic"/>
+                        </a:rPr>
+                        <a:t>0.114</a:t>
+                      </a:r>
+                    </a:p>
+                  </a:txBody>
+                  <a:tcPr marL="82296" marR="82296" marT="41148" marB="41148" anchor="ctr">
+                    <a:solidFill>
+                      <a:srgbClr val="F7F7F9"/>
+                    </a:solidFill>
+                  </a:tcPr>
+                </a:tc>
+                <a:tc>
+                  <a:txBody>
+                    <a:bodyPr wrap="square"/>
+                    <a:lstStyle/>
+                    <a:p>
+                      <a:pPr algn="r">
+                        <a:lnSpc>
+                          <a:spcPct val="115000"/>
+                        </a:lnSpc>
+                      </a:pPr>
+                      <a:r>
+                        <a:rPr sz="950" b="1">
+                          <a:solidFill>
+                            <a:srgbClr val="C1442A"/>
+                          </a:solidFill>
+                          <a:latin typeface="Malgun Gothic"/>
+                          <a:ea typeface="Malgun Gothic"/>
+                          <a:cs typeface="Malgun Gothic"/>
+                        </a:rPr>
+                        <a:t>0.086</a:t>
+                      </a:r>
+                    </a:p>
+                  </a:txBody>
+                  <a:tcPr marL="82296" marR="82296" marT="41148" marB="41148" anchor="ctr">
+                    <a:solidFill>
+                      <a:srgbClr val="F7F7F9"/>
+                    </a:solidFill>
+                  </a:tcPr>
+                </a:tc>
+                <a:tc>
+                  <a:txBody>
+                    <a:bodyPr wrap="square"/>
+                    <a:lstStyle/>
+                    <a:p>
+                      <a:pPr algn="r">
+                        <a:lnSpc>
+                          <a:spcPct val="115000"/>
+                        </a:lnSpc>
+                      </a:pPr>
+                      <a:r>
+                        <a:rPr sz="950" b="0">
+                          <a:solidFill>
+                            <a:srgbClr val="565C66"/>
+                          </a:solidFill>
+                          <a:latin typeface="Malgun Gothic"/>
+                          <a:ea typeface="Malgun Gothic"/>
+                          <a:cs typeface="Malgun Gothic"/>
+                        </a:rPr>
+                        <a:t>0.114</a:t>
+                      </a:r>
+                    </a:p>
+                  </a:txBody>
+                  <a:tcPr marL="82296" marR="82296" marT="41148" marB="41148" anchor="ctr">
+                    <a:solidFill>
+                      <a:srgbClr val="F7F7F9"/>
+                    </a:solidFill>
+                  </a:tcPr>
+                </a:tc>
+                <a:tc>
+                  <a:txBody>
+                    <a:bodyPr wrap="square"/>
+                    <a:lstStyle/>
+                    <a:p>
+                      <a:pPr algn="ctr">
+                        <a:lnSpc>
+                          <a:spcPct val="115000"/>
+                        </a:lnSpc>
+                      </a:pPr>
+                      <a:r>
+                        <a:rPr sz="950" b="0">
+                          <a:solidFill>
+                            <a:srgbClr val="565C66"/>
+                          </a:solidFill>
+                          <a:latin typeface="Malgun Gothic"/>
+                          <a:ea typeface="Malgun Gothic"/>
+                          <a:cs typeface="Malgun Gothic"/>
+                        </a:rPr>
+                        <a:t>0</a:t>
+                      </a:r>
+                    </a:p>
+                  </a:txBody>
+                  <a:tcPr marL="82296" marR="82296" marT="41148" marB="41148" anchor="ctr">
+                    <a:solidFill>
+                      <a:srgbClr val="F7F7F9"/>
+                    </a:solidFill>
+                  </a:tcPr>
+                </a:tc>
+                <a:tc>
+                  <a:txBody>
+                    <a:bodyPr wrap="square"/>
+                    <a:lstStyle/>
+                    <a:p>
+                      <a:pPr algn="ctr">
+                        <a:lnSpc>
+                          <a:spcPct val="115000"/>
+                        </a:lnSpc>
+                      </a:pPr>
+                      <a:r>
+                        <a:rPr sz="950" b="0">
+                          <a:solidFill>
+                            <a:srgbClr val="565C66"/>
+                          </a:solidFill>
+                          <a:latin typeface="Malgun Gothic"/>
+                          <a:ea typeface="Malgun Gothic"/>
+                          <a:cs typeface="Malgun Gothic"/>
+                        </a:rPr>
+                        <a:t>4</a:t>
+                      </a:r>
+                    </a:p>
+                  </a:txBody>
+                  <a:tcPr marL="82296" marR="82296" marT="41148" marB="41148" anchor="ctr">
+                    <a:solidFill>
+                      <a:srgbClr val="F7F7F9"/>
+                    </a:solidFill>
+                  </a:tcPr>
+                </a:tc>
+              </a:tr>
+              <a:tr h="402336">
+                <a:tc>
+                  <a:txBody>
+                    <a:bodyPr wrap="square"/>
+                    <a:lstStyle/>
+                    <a:p>
+                      <a:pPr algn="l">
+                        <a:lnSpc>
+                          <a:spcPct val="115000"/>
                         </a:lnSpc>
                       </a:pPr>
                       <a:r>
                         <a:rPr sz="900" b="1">
                           <a:solidFill>
-                            <a:srgbClr val="8B9099"/>
-                          </a:solidFill>
-                          <a:latin typeface="Malgun Gothic"/>
-                          <a:ea typeface="Malgun Gothic"/>
-                          <a:cs typeface="Malgun Gothic"/>
-                        </a:rPr>
-                        <a:t>GPU / quant</a:t>
-                      </a:r>
-                    </a:p>
-                  </a:txBody>
-                  <a:tcPr marL="82296" marR="82296" marT="41148" marB="41148" anchor="ctr">
-                    <a:solidFill>
-                      <a:srgbClr val="E9EAED"/>
+                            <a:srgbClr val="2F6FCE"/>
+                          </a:solidFill>
+                          <a:latin typeface="Malgun Gothic"/>
+                          <a:ea typeface="Malgun Gothic"/>
+                          <a:cs typeface="Malgun Gothic"/>
+                        </a:rPr>
+                        <a:t>32B bf16</a:t>
+                      </a:r>
+                    </a:p>
+                  </a:txBody>
+                  <a:tcPr marL="82296" marR="82296" marT="41148" marB="41148" anchor="ctr">
+                    <a:solidFill>
+                      <a:srgbClr val="FFFFFF"/>
+                    </a:solidFill>
+                  </a:tcPr>
+                </a:tc>
+                <a:tc>
+                  <a:txBody>
+                    <a:bodyPr wrap="square"/>
+                    <a:lstStyle/>
+                    <a:p>
+                      <a:pPr algn="l">
+                        <a:lnSpc>
+                          <a:spcPct val="115000"/>
+                        </a:lnSpc>
+                      </a:pPr>
+                      <a:r>
+                        <a:rPr sz="850" b="1">
+                          <a:solidFill>
+                            <a:srgbClr val="16181D"/>
+                          </a:solidFill>
+                          <a:latin typeface="Malgun Gothic"/>
+                          <a:ea typeface="Malgun Gothic"/>
+                          <a:cs typeface="Malgun Gothic"/>
+                        </a:rPr>
+                        <a:t>A6000 / bf16</a:t>
+                      </a:r>
+                    </a:p>
+                  </a:txBody>
+                  <a:tcPr marL="82296" marR="82296" marT="41148" marB="41148" anchor="ctr">
+                    <a:solidFill>
+                      <a:srgbClr val="FFFFFF"/>
                     </a:solidFill>
                   </a:tcPr>
                 </a:tc>
@@ -4634,25 +5378,25 @@
                     <a:p>
                       <a:pPr algn="r">
                         <a:lnSpc>
-                          <a:spcPct val="100000"/>
-                        </a:lnSpc>
-                      </a:pPr>
-                      <a:r>
-                        <a:rPr sz="1000" b="1">
-                          <a:solidFill>
-                            <a:srgbClr val="8B9099"/>
-                          </a:solidFill>
-                          <a:latin typeface="Malgun Gothic"/>
-                          <a:ea typeface="Malgun Gothic"/>
-                          <a:cs typeface="Malgun Gothic"/>
-                        </a:rPr>
-                        <a:t>slack k0</a:t>
-                      </a:r>
-                    </a:p>
-                  </a:txBody>
-                  <a:tcPr marL="82296" marR="82296" marT="41148" marB="41148" anchor="ctr">
-                    <a:solidFill>
-                      <a:srgbClr val="E9EAED"/>
+                          <a:spcPct val="115000"/>
+                        </a:lnSpc>
+                      </a:pPr>
+                      <a:r>
+                        <a:rPr sz="950" b="0">
+                          <a:solidFill>
+                            <a:srgbClr val="565C66"/>
+                          </a:solidFill>
+                          <a:latin typeface="Malgun Gothic"/>
+                          <a:ea typeface="Malgun Gothic"/>
+                          <a:cs typeface="Malgun Gothic"/>
+                        </a:rPr>
+                        <a:t>0.257</a:t>
+                      </a:r>
+                    </a:p>
+                  </a:txBody>
+                  <a:tcPr marL="82296" marR="82296" marT="41148" marB="41148" anchor="ctr">
+                    <a:solidFill>
+                      <a:srgbClr val="FFFFFF"/>
                     </a:solidFill>
                   </a:tcPr>
                 </a:tc>
@@ -4663,25 +5407,25 @@
                     <a:p>
                       <a:pPr algn="r">
                         <a:lnSpc>
-                          <a:spcPct val="100000"/>
-                        </a:lnSpc>
-                      </a:pPr>
-                      <a:r>
-                        <a:rPr sz="1000" b="1">
-                          <a:solidFill>
-                            <a:srgbClr val="8B9099"/>
-                          </a:solidFill>
-                          <a:latin typeface="Malgun Gothic"/>
-                          <a:ea typeface="Malgun Gothic"/>
-                          <a:cs typeface="Malgun Gothic"/>
-                        </a:rPr>
-                        <a:t>slack kN</a:t>
-                      </a:r>
-                    </a:p>
-                  </a:txBody>
-                  <a:tcPr marL="82296" marR="82296" marT="41148" marB="41148" anchor="ctr">
-                    <a:solidFill>
-                      <a:srgbClr val="E9EAED"/>
+                          <a:spcPct val="115000"/>
+                        </a:lnSpc>
+                      </a:pPr>
+                      <a:r>
+                        <a:rPr sz="950" b="1">
+                          <a:solidFill>
+                            <a:srgbClr val="C1442A"/>
+                          </a:solidFill>
+                          <a:latin typeface="Malgun Gothic"/>
+                          <a:ea typeface="Malgun Gothic"/>
+                          <a:cs typeface="Malgun Gothic"/>
+                        </a:rPr>
+                        <a:t>0.143</a:t>
+                      </a:r>
+                    </a:p>
+                  </a:txBody>
+                  <a:tcPr marL="82296" marR="82296" marT="41148" marB="41148" anchor="ctr">
+                    <a:solidFill>
+                      <a:srgbClr val="FFFFFF"/>
                     </a:solidFill>
                   </a:tcPr>
                 </a:tc>
@@ -4692,25 +5436,83 @@
                     <a:p>
                       <a:pPr algn="r">
                         <a:lnSpc>
-                          <a:spcPct val="100000"/>
+                          <a:spcPct val="115000"/>
+                        </a:lnSpc>
+                      </a:pPr>
+                      <a:r>
+                        <a:rPr sz="950" b="0">
+                          <a:solidFill>
+                            <a:srgbClr val="565C66"/>
+                          </a:solidFill>
+                          <a:latin typeface="Malgun Gothic"/>
+                          <a:ea typeface="Malgun Gothic"/>
+                          <a:cs typeface="Malgun Gothic"/>
+                        </a:rPr>
+                        <a:t>0.286</a:t>
+                      </a:r>
+                    </a:p>
+                  </a:txBody>
+                  <a:tcPr marL="82296" marR="82296" marT="41148" marB="41148" anchor="ctr">
+                    <a:solidFill>
+                      <a:srgbClr val="FFFFFF"/>
+                    </a:solidFill>
+                  </a:tcPr>
+                </a:tc>
+                <a:tc>
+                  <a:txBody>
+                    <a:bodyPr wrap="square"/>
+                    <a:lstStyle/>
+                    <a:p>
+                      <a:pPr algn="r">
+                        <a:lnSpc>
+                          <a:spcPct val="115000"/>
+                        </a:lnSpc>
+                      </a:pPr>
+                      <a:r>
+                        <a:rPr sz="950" b="0">
+                          <a:solidFill>
+                            <a:srgbClr val="565C66"/>
+                          </a:solidFill>
+                          <a:latin typeface="Malgun Gothic"/>
+                          <a:ea typeface="Malgun Gothic"/>
+                          <a:cs typeface="Malgun Gothic"/>
+                        </a:rPr>
+                        <a:t>0.314</a:t>
+                      </a:r>
+                    </a:p>
+                  </a:txBody>
+                  <a:tcPr marL="82296" marR="82296" marT="41148" marB="41148" anchor="ctr">
+                    <a:solidFill>
+                      <a:srgbClr val="FFFFFF"/>
+                    </a:solidFill>
+                  </a:tcPr>
+                </a:tc>
+                <a:tc>
+                  <a:txBody>
+                    <a:bodyPr wrap="square"/>
+                    <a:lstStyle/>
+                    <a:p>
+                      <a:pPr algn="ctr">
+                        <a:lnSpc>
+                          <a:spcPct val="115000"/>
                         </a:lnSpc>
                       </a:pPr>
                       <a:r>
                         <a:rPr sz="950" b="1">
                           <a:solidFill>
-                            <a:srgbClr val="8B9099"/>
-                          </a:solidFill>
-                          <a:latin typeface="Malgun Gothic"/>
-                          <a:ea typeface="Malgun Gothic"/>
-                          <a:cs typeface="Malgun Gothic"/>
-                        </a:rPr>
-                        <a:t>slack k0_util</a:t>
-                      </a:r>
-                    </a:p>
-                  </a:txBody>
-                  <a:tcPr marL="82296" marR="82296" marT="41148" marB="41148" anchor="ctr">
-                    <a:solidFill>
-                      <a:srgbClr val="E9EAED"/>
+                            <a:srgbClr val="C1442A"/>
+                          </a:solidFill>
+                          <a:latin typeface="Malgun Gothic"/>
+                          <a:ea typeface="Malgun Gothic"/>
+                          <a:cs typeface="Malgun Gothic"/>
+                        </a:rPr>
+                        <a:t>1</a:t>
+                      </a:r>
+                    </a:p>
+                  </a:txBody>
+                  <a:tcPr marL="82296" marR="82296" marT="41148" marB="41148" anchor="ctr">
+                    <a:solidFill>
+                      <a:srgbClr val="FFFFFF"/>
                     </a:solidFill>
                   </a:tcPr>
                 </a:tc>
@@ -4721,25 +5523,201 @@
                     <a:p>
                       <a:pPr algn="ctr">
                         <a:lnSpc>
-                          <a:spcPct val="100000"/>
-                        </a:lnSpc>
-                      </a:pPr>
-                      <a:r>
-                        <a:rPr sz="1000" b="1">
-                          <a:solidFill>
-                            <a:srgbClr val="8B9099"/>
-                          </a:solidFill>
-                          <a:latin typeface="Malgun Gothic"/>
-                          <a:ea typeface="Malgun Gothic"/>
-                          <a:cs typeface="Malgun Gothic"/>
-                        </a:rPr>
-                        <a:t>backfire</a:t>
-                      </a:r>
-                    </a:p>
-                  </a:txBody>
-                  <a:tcPr marL="82296" marR="82296" marT="41148" marB="41148" anchor="ctr">
-                    <a:solidFill>
-                      <a:srgbClr val="E9EAED"/>
+                          <a:spcPct val="115000"/>
+                        </a:lnSpc>
+                      </a:pPr>
+                      <a:r>
+                        <a:rPr sz="950" b="0">
+                          <a:solidFill>
+                            <a:srgbClr val="565C66"/>
+                          </a:solidFill>
+                          <a:latin typeface="Malgun Gothic"/>
+                          <a:ea typeface="Malgun Gothic"/>
+                          <a:cs typeface="Malgun Gothic"/>
+                        </a:rPr>
+                        <a:t>4</a:t>
+                      </a:r>
+                    </a:p>
+                  </a:txBody>
+                  <a:tcPr marL="82296" marR="82296" marT="41148" marB="41148" anchor="ctr">
+                    <a:solidFill>
+                      <a:srgbClr val="FFFFFF"/>
+                    </a:solidFill>
+                  </a:tcPr>
+                </a:tc>
+              </a:tr>
+              <a:tr h="402336">
+                <a:tc>
+                  <a:txBody>
+                    <a:bodyPr wrap="square"/>
+                    <a:lstStyle/>
+                    <a:p>
+                      <a:pPr algn="l">
+                        <a:lnSpc>
+                          <a:spcPct val="115000"/>
+                        </a:lnSpc>
+                      </a:pPr>
+                      <a:r>
+                        <a:rPr sz="900" b="0">
+                          <a:solidFill>
+                            <a:srgbClr val="565C66"/>
+                          </a:solidFill>
+                          <a:latin typeface="Malgun Gothic"/>
+                          <a:ea typeface="Malgun Gothic"/>
+                          <a:cs typeface="Malgun Gothic"/>
+                        </a:rPr>
+                        <a:t>(대조) 7B bf16</a:t>
+                      </a:r>
+                    </a:p>
+                  </a:txBody>
+                  <a:tcPr marL="82296" marR="82296" marT="41148" marB="41148" anchor="ctr">
+                    <a:solidFill>
+                      <a:srgbClr val="F7F7F9"/>
+                    </a:solidFill>
+                  </a:tcPr>
+                </a:tc>
+                <a:tc>
+                  <a:txBody>
+                    <a:bodyPr wrap="square"/>
+                    <a:lstStyle/>
+                    <a:p>
+                      <a:pPr algn="l">
+                        <a:lnSpc>
+                          <a:spcPct val="115000"/>
+                        </a:lnSpc>
+                      </a:pPr>
+                      <a:r>
+                        <a:rPr sz="850" b="0">
+                          <a:solidFill>
+                            <a:srgbClr val="565C66"/>
+                          </a:solidFill>
+                          <a:latin typeface="Malgun Gothic"/>
+                          <a:ea typeface="Malgun Gothic"/>
+                          <a:cs typeface="Malgun Gothic"/>
+                        </a:rPr>
+                        <a:t>4090 / bf16</a:t>
+                      </a:r>
+                    </a:p>
+                  </a:txBody>
+                  <a:tcPr marL="82296" marR="82296" marT="41148" marB="41148" anchor="ctr">
+                    <a:solidFill>
+                      <a:srgbClr val="F7F7F9"/>
+                    </a:solidFill>
+                  </a:tcPr>
+                </a:tc>
+                <a:tc>
+                  <a:txBody>
+                    <a:bodyPr wrap="square"/>
+                    <a:lstStyle/>
+                    <a:p>
+                      <a:pPr algn="r">
+                        <a:lnSpc>
+                          <a:spcPct val="115000"/>
+                        </a:lnSpc>
+                      </a:pPr>
+                      <a:r>
+                        <a:rPr sz="950" b="0">
+                          <a:solidFill>
+                            <a:srgbClr val="565C66"/>
+                          </a:solidFill>
+                          <a:latin typeface="Malgun Gothic"/>
+                          <a:ea typeface="Malgun Gothic"/>
+                          <a:cs typeface="Malgun Gothic"/>
+                        </a:rPr>
+                        <a:t>0.171</a:t>
+                      </a:r>
+                    </a:p>
+                  </a:txBody>
+                  <a:tcPr marL="82296" marR="82296" marT="41148" marB="41148" anchor="ctr">
+                    <a:solidFill>
+                      <a:srgbClr val="F7F7F9"/>
+                    </a:solidFill>
+                  </a:tcPr>
+                </a:tc>
+                <a:tc>
+                  <a:txBody>
+                    <a:bodyPr wrap="square"/>
+                    <a:lstStyle/>
+                    <a:p>
+                      <a:pPr algn="r">
+                        <a:lnSpc>
+                          <a:spcPct val="115000"/>
+                        </a:lnSpc>
+                      </a:pPr>
+                      <a:r>
+                        <a:rPr sz="950" b="1">
+                          <a:solidFill>
+                            <a:srgbClr val="2F6FCE"/>
+                          </a:solidFill>
+                          <a:latin typeface="Malgun Gothic"/>
+                          <a:ea typeface="Malgun Gothic"/>
+                          <a:cs typeface="Malgun Gothic"/>
+                        </a:rPr>
+                        <a:t>0.000</a:t>
+                      </a:r>
+                    </a:p>
+                  </a:txBody>
+                  <a:tcPr marL="82296" marR="82296" marT="41148" marB="41148" anchor="ctr">
+                    <a:solidFill>
+                      <a:srgbClr val="F7F7F9"/>
+                    </a:solidFill>
+                  </a:tcPr>
+                </a:tc>
+                <a:tc>
+                  <a:txBody>
+                    <a:bodyPr wrap="square"/>
+                    <a:lstStyle/>
+                    <a:p>
+                      <a:pPr algn="r">
+                        <a:lnSpc>
+                          <a:spcPct val="115000"/>
+                        </a:lnSpc>
+                      </a:pPr>
+                      <a:r>
+                        <a:rPr sz="950" b="0">
+                          <a:solidFill>
+                            <a:srgbClr val="565C66"/>
+                          </a:solidFill>
+                          <a:latin typeface="Malgun Gothic"/>
+                          <a:ea typeface="Malgun Gothic"/>
+                          <a:cs typeface="Malgun Gothic"/>
+                        </a:rPr>
+                        <a:t>0.371</a:t>
+                      </a:r>
+                    </a:p>
+                  </a:txBody>
+                  <a:tcPr marL="82296" marR="82296" marT="41148" marB="41148" anchor="ctr">
+                    <a:solidFill>
+                      <a:srgbClr val="F7F7F9"/>
+                    </a:solidFill>
+                  </a:tcPr>
+                </a:tc>
+                <a:tc>
+                  <a:txBody>
+                    <a:bodyPr wrap="square"/>
+                    <a:lstStyle/>
+                    <a:p>
+                      <a:pPr algn="r">
+                        <a:lnSpc>
+                          <a:spcPct val="115000"/>
+                        </a:lnSpc>
+                      </a:pPr>
+                      <a:r>
+                        <a:rPr sz="950" b="0">
+                          <a:solidFill>
+                            <a:srgbClr val="565C66"/>
+                          </a:solidFill>
+                          <a:latin typeface="Malgun Gothic"/>
+                          <a:ea typeface="Malgun Gothic"/>
+                          <a:cs typeface="Malgun Gothic"/>
+                        </a:rPr>
+                        <a:t>0.429</a:t>
+                      </a:r>
+                    </a:p>
+                  </a:txBody>
+                  <a:tcPr marL="82296" marR="82296" marT="41148" marB="41148" anchor="ctr">
+                    <a:solidFill>
+                      <a:srgbClr val="F7F7F9"/>
                     </a:solidFill>
                   </a:tcPr>
                 </a:tc>
@@ -4750,30 +5728,59 @@
                     <a:p>
                       <a:pPr algn="ctr">
                         <a:lnSpc>
-                          <a:spcPct val="100000"/>
-                        </a:lnSpc>
-                      </a:pPr>
-                      <a:r>
-                        <a:rPr sz="1000" b="1">
-                          <a:solidFill>
-                            <a:srgbClr val="8B9099"/>
-                          </a:solidFill>
-                          <a:latin typeface="Malgun Gothic"/>
-                          <a:ea typeface="Malgun Gothic"/>
-                          <a:cs typeface="Malgun Gothic"/>
-                        </a:rPr>
-                        <a:t>persist</a:t>
-                      </a:r>
-                    </a:p>
-                  </a:txBody>
-                  <a:tcPr marL="82296" marR="82296" marT="41148" marB="41148" anchor="ctr">
-                    <a:solidFill>
-                      <a:srgbClr val="E9EAED"/>
+                          <a:spcPct val="115000"/>
+                        </a:lnSpc>
+                      </a:pPr>
+                      <a:r>
+                        <a:rPr sz="950" b="1">
+                          <a:solidFill>
+                            <a:srgbClr val="2F6FCE"/>
+                          </a:solidFill>
+                          <a:latin typeface="Malgun Gothic"/>
+                          <a:ea typeface="Malgun Gothic"/>
+                          <a:cs typeface="Malgun Gothic"/>
+                        </a:rPr>
+                        <a:t>0</a:t>
+                      </a:r>
+                    </a:p>
+                  </a:txBody>
+                  <a:tcPr marL="82296" marR="82296" marT="41148" marB="41148" anchor="ctr">
+                    <a:solidFill>
+                      <a:srgbClr val="F7F7F9"/>
+                    </a:solidFill>
+                  </a:tcPr>
+                </a:tc>
+                <a:tc>
+                  <a:txBody>
+                    <a:bodyPr wrap="square"/>
+                    <a:lstStyle/>
+                    <a:p>
+                      <a:pPr algn="ctr">
+                        <a:lnSpc>
+                          <a:spcPct val="115000"/>
+                        </a:lnSpc>
+                      </a:pPr>
+                      <a:r>
+                        <a:rPr sz="950" b="0">
+                          <a:solidFill>
+                            <a:srgbClr val="565C66"/>
+                          </a:solidFill>
+                          <a:latin typeface="Malgun Gothic"/>
+                          <a:ea typeface="Malgun Gothic"/>
+                          <a:cs typeface="Malgun Gothic"/>
+                        </a:rPr>
+                        <a:t>0</a:t>
+                      </a:r>
+                    </a:p>
+                  </a:txBody>
+                  <a:tcPr marL="82296" marR="82296" marT="41148" marB="41148" anchor="ctr">
+                    <a:solidFill>
+                      <a:srgbClr val="F7F7F9"/>
                     </a:solidFill>
                   </a:tcPr>
                 </a:tc>
               </a:tr>
-              <a:tr h="420624">
+              <a:tr h="402336">
                 <a:tc>
                   <a:txBody>
                     <a:bodyPr wrap="square"/>
@@ -4785,6 +5792,64 @@
                         </a:lnSpc>
                       </a:pPr>
                       <a:r>
+                        <a:rPr sz="900" b="0">
+                          <a:solidFill>
+                            <a:srgbClr val="565C66"/>
+                          </a:solidFill>
+                          <a:latin typeface="Malgun Gothic"/>
+                          <a:ea typeface="Malgun Gothic"/>
+                          <a:cs typeface="Malgun Gothic"/>
+                        </a:rPr>
+                        <a:t>(대조) Llama-8B bf16</a:t>
+                      </a:r>
+                    </a:p>
+                  </a:txBody>
+                  <a:tcPr marL="82296" marR="82296" marT="41148" marB="41148" anchor="ctr">
+                    <a:solidFill>
+                      <a:srgbClr val="FFFFFF"/>
+                    </a:solidFill>
+                  </a:tcPr>
+                </a:tc>
+                <a:tc>
+                  <a:txBody>
+                    <a:bodyPr wrap="square"/>
+                    <a:lstStyle/>
+                    <a:p>
+                      <a:pPr algn="l">
+                        <a:lnSpc>
+                          <a:spcPct val="115000"/>
+                        </a:lnSpc>
+                      </a:pPr>
+                      <a:r>
+                        <a:rPr sz="850" b="0">
+                          <a:solidFill>
+                            <a:srgbClr val="565C66"/>
+                          </a:solidFill>
+                          <a:latin typeface="Malgun Gothic"/>
+                          <a:ea typeface="Malgun Gothic"/>
+                          <a:cs typeface="Malgun Gothic"/>
+                        </a:rPr>
+                        <a:t>A6000 / bf16</a:t>
+                      </a:r>
+                    </a:p>
+                  </a:txBody>
+                  <a:tcPr marL="82296" marR="82296" marT="41148" marB="41148" anchor="ctr">
+                    <a:solidFill>
+                      <a:srgbClr val="FFFFFF"/>
+                    </a:solidFill>
+                  </a:tcPr>
+                </a:tc>
+                <a:tc>
+                  <a:txBody>
+                    <a:bodyPr wrap="square"/>
+                    <a:lstStyle/>
+                    <a:p>
+                      <a:pPr algn="r">
+                        <a:lnSpc>
+                          <a:spcPct val="115000"/>
+                        </a:lnSpc>
+                      </a:pPr>
+                      <a:r>
                         <a:rPr sz="950" b="0">
                           <a:solidFill>
                             <a:srgbClr val="565C66"/>
@@ -4793,7 +5858,7 @@
                           <a:ea typeface="Malgun Gothic"/>
                           <a:cs typeface="Malgun Gothic"/>
                         </a:rPr>
-                        <a:t>32B nf4dq  (×3 동일)</a:t>
+                        <a:t>0.200</a:t>
                       </a:r>
                     </a:p>
                   </a:txBody>
@@ -4808,13 +5873,42 @@
                     <a:bodyPr wrap="square"/>
                     <a:lstStyle/>
                     <a:p>
-                      <a:pPr algn="l">
-                        <a:lnSpc>
-                          <a:spcPct val="115000"/>
-                        </a:lnSpc>
-                      </a:pPr>
-                      <a:r>
-                        <a:rPr sz="900" b="0">
+                      <a:pPr algn="r">
+                        <a:lnSpc>
+                          <a:spcPct val="115000"/>
+                        </a:lnSpc>
+                      </a:pPr>
+                      <a:r>
+                        <a:rPr sz="950" b="1">
+                          <a:solidFill>
+                            <a:srgbClr val="2F6FCE"/>
+                          </a:solidFill>
+                          <a:latin typeface="Malgun Gothic"/>
+                          <a:ea typeface="Malgun Gothic"/>
+                          <a:cs typeface="Malgun Gothic"/>
+                        </a:rPr>
+                        <a:t>0.000</a:t>
+                      </a:r>
+                    </a:p>
+                  </a:txBody>
+                  <a:tcPr marL="82296" marR="82296" marT="41148" marB="41148" anchor="ctr">
+                    <a:solidFill>
+                      <a:srgbClr val="FFFFFF"/>
+                    </a:solidFill>
+                  </a:tcPr>
+                </a:tc>
+                <a:tc>
+                  <a:txBody>
+                    <a:bodyPr wrap="square"/>
+                    <a:lstStyle/>
+                    <a:p>
+                      <a:pPr algn="r">
+                        <a:lnSpc>
+                          <a:spcPct val="115000"/>
+                        </a:lnSpc>
+                      </a:pPr>
+                      <a:r>
+                        <a:rPr sz="950" b="0">
                           <a:solidFill>
                             <a:srgbClr val="565C66"/>
                           </a:solidFill>
@@ -4822,7 +5916,7 @@
                           <a:ea typeface="Malgun Gothic"/>
                           <a:cs typeface="Malgun Gothic"/>
                         </a:rPr>
-                        <a:t>A6000 sm_86 / nf4dq</a:t>
+                        <a:t>0.314</a:t>
                       </a:r>
                     </a:p>
                   </a:txBody>
@@ -4843,7 +5937,7 @@
                         </a:lnSpc>
                       </a:pPr>
                       <a:r>
-                        <a:rPr sz="1000" b="0">
+                        <a:rPr sz="950" b="0">
                           <a:solidFill>
                             <a:srgbClr val="565C66"/>
                           </a:solidFill>
@@ -4851,7 +5945,7 @@
                           <a:ea typeface="Malgun Gothic"/>
                           <a:cs typeface="Malgun Gothic"/>
                         </a:rPr>
-                        <a:t>0.229</a:t>
+                        <a:t>0.286</a:t>
                       </a:r>
                     </a:p>
                   </a:txBody>
@@ -4866,13 +5960,42 @@
                     <a:bodyPr wrap="square"/>
                     <a:lstStyle/>
                     <a:p>
-                      <a:pPr algn="r">
-                        <a:lnSpc>
-                          <a:spcPct val="115000"/>
-                        </a:lnSpc>
-                      </a:pPr>
-                      <a:r>
-                        <a:rPr sz="1000" b="0">
+                      <a:pPr algn="ctr">
+                        <a:lnSpc>
+                          <a:spcPct val="115000"/>
+                        </a:lnSpc>
+                      </a:pPr>
+                      <a:r>
+                        <a:rPr sz="950" b="1">
+                          <a:solidFill>
+                            <a:srgbClr val="2F6FCE"/>
+                          </a:solidFill>
+                          <a:latin typeface="Malgun Gothic"/>
+                          <a:ea typeface="Malgun Gothic"/>
+                          <a:cs typeface="Malgun Gothic"/>
+                        </a:rPr>
+                        <a:t>0</a:t>
+                      </a:r>
+                    </a:p>
+                  </a:txBody>
+                  <a:tcPr marL="82296" marR="82296" marT="41148" marB="41148" anchor="ctr">
+                    <a:solidFill>
+                      <a:srgbClr val="FFFFFF"/>
+                    </a:solidFill>
+                  </a:tcPr>
+                </a:tc>
+                <a:tc>
+                  <a:txBody>
+                    <a:bodyPr wrap="square"/>
+                    <a:lstStyle/>
+                    <a:p>
+                      <a:pPr algn="ctr">
+                        <a:lnSpc>
+                          <a:spcPct val="115000"/>
+                        </a:lnSpc>
+                      </a:pPr>
+                      <a:r>
+                        <a:rPr sz="950" b="0">
                           <a:solidFill>
                             <a:srgbClr val="565C66"/>
                           </a:solidFill>
@@ -4880,715 +6003,13 @@
                           <a:ea typeface="Malgun Gothic"/>
                           <a:cs typeface="Malgun Gothic"/>
                         </a:rPr>
-                        <a:t>0.229</a:t>
+                        <a:t>0</a:t>
                       </a:r>
                     </a:p>
                   </a:txBody>
                   <a:tcPr marL="82296" marR="82296" marT="41148" marB="41148" anchor="ctr">
                     <a:solidFill>
                       <a:srgbClr val="FFFFFF"/>
-                    </a:solidFill>
-                  </a:tcPr>
-                </a:tc>
-                <a:tc>
-                  <a:txBody>
-                    <a:bodyPr wrap="square"/>
-                    <a:lstStyle/>
-                    <a:p>
-                      <a:pPr algn="r">
-                        <a:lnSpc>
-                          <a:spcPct val="115000"/>
-                        </a:lnSpc>
-                      </a:pPr>
-                      <a:r>
-                        <a:rPr sz="950" b="0">
-                          <a:solidFill>
-                            <a:srgbClr val="565C66"/>
-                          </a:solidFill>
-                          <a:latin typeface="Malgun Gothic"/>
-                          <a:ea typeface="Malgun Gothic"/>
-                          <a:cs typeface="Malgun Gothic"/>
-                        </a:rPr>
-                        <a:t>0.286</a:t>
-                      </a:r>
-                    </a:p>
-                  </a:txBody>
-                  <a:tcPr marL="82296" marR="82296" marT="41148" marB="41148" anchor="ctr">
-                    <a:solidFill>
-                      <a:srgbClr val="FFFFFF"/>
-                    </a:solidFill>
-                  </a:tcPr>
-                </a:tc>
-                <a:tc>
-                  <a:txBody>
-                    <a:bodyPr wrap="square"/>
-                    <a:lstStyle/>
-                    <a:p>
-                      <a:pPr algn="ctr">
-                        <a:lnSpc>
-                          <a:spcPct val="115000"/>
-                        </a:lnSpc>
-                      </a:pPr>
-                      <a:r>
-                        <a:rPr sz="1000" b="0">
-                          <a:solidFill>
-                            <a:srgbClr val="565C66"/>
-                          </a:solidFill>
-                          <a:latin typeface="Malgun Gothic"/>
-                          <a:ea typeface="Malgun Gothic"/>
-                          <a:cs typeface="Malgun Gothic"/>
-                        </a:rPr>
-                        <a:t>2</a:t>
-                      </a:r>
-                    </a:p>
-                  </a:txBody>
-                  <a:tcPr marL="82296" marR="82296" marT="41148" marB="41148" anchor="ctr">
-                    <a:solidFill>
-                      <a:srgbClr val="FFFFFF"/>
-                    </a:solidFill>
-                  </a:tcPr>
-                </a:tc>
-                <a:tc>
-                  <a:txBody>
-                    <a:bodyPr wrap="square"/>
-                    <a:lstStyle/>
-                    <a:p>
-                      <a:pPr algn="ctr">
-                        <a:lnSpc>
-                          <a:spcPct val="115000"/>
-                        </a:lnSpc>
-                      </a:pPr>
-                      <a:r>
-                        <a:rPr sz="1000" b="0">
-                          <a:solidFill>
-                            <a:srgbClr val="565C66"/>
-                          </a:solidFill>
-                          <a:latin typeface="Malgun Gothic"/>
-                          <a:ea typeface="Malgun Gothic"/>
-                          <a:cs typeface="Malgun Gothic"/>
-                        </a:rPr>
-                        <a:t>6</a:t>
-                      </a:r>
-                    </a:p>
-                  </a:txBody>
-                  <a:tcPr marL="82296" marR="82296" marT="41148" marB="41148" anchor="ctr">
-                    <a:solidFill>
-                      <a:srgbClr val="FFFFFF"/>
-                    </a:solidFill>
-                  </a:tcPr>
-                </a:tc>
-              </a:tr>
-              <a:tr h="420624">
-                <a:tc>
-                  <a:txBody>
-                    <a:bodyPr wrap="square"/>
-                    <a:lstStyle/>
-                    <a:p>
-                      <a:pPr algn="l">
-                        <a:lnSpc>
-                          <a:spcPct val="115000"/>
-                        </a:lnSpc>
-                      </a:pPr>
-                      <a:r>
-                        <a:rPr sz="950" b="0">
-                          <a:solidFill>
-                            <a:srgbClr val="565C66"/>
-                          </a:solidFill>
-                          <a:latin typeface="Malgun Gothic"/>
-                          <a:ea typeface="Malgun Gothic"/>
-                          <a:cs typeface="Malgun Gothic"/>
-                        </a:rPr>
-                        <a:t>32B nf4dq  (×5 동일)</a:t>
-                      </a:r>
-                    </a:p>
-                  </a:txBody>
-                  <a:tcPr marL="82296" marR="82296" marT="41148" marB="41148" anchor="ctr">
-                    <a:solidFill>
-                      <a:srgbClr val="F7F7F9"/>
-                    </a:solidFill>
-                  </a:tcPr>
-                </a:tc>
-                <a:tc>
-                  <a:txBody>
-                    <a:bodyPr wrap="square"/>
-                    <a:lstStyle/>
-                    <a:p>
-                      <a:pPr algn="l">
-                        <a:lnSpc>
-                          <a:spcPct val="115000"/>
-                        </a:lnSpc>
-                      </a:pPr>
-                      <a:r>
-                        <a:rPr sz="900" b="0">
-                          <a:solidFill>
-                            <a:srgbClr val="565C66"/>
-                          </a:solidFill>
-                          <a:latin typeface="Malgun Gothic"/>
-                          <a:ea typeface="Malgun Gothic"/>
-                          <a:cs typeface="Malgun Gothic"/>
-                        </a:rPr>
-                        <a:t>Blackwell sm_120 / nf4dq</a:t>
-                      </a:r>
-                    </a:p>
-                  </a:txBody>
-                  <a:tcPr marL="82296" marR="82296" marT="41148" marB="41148" anchor="ctr">
-                    <a:solidFill>
-                      <a:srgbClr val="F7F7F9"/>
-                    </a:solidFill>
-                  </a:tcPr>
-                </a:tc>
-                <a:tc>
-                  <a:txBody>
-                    <a:bodyPr wrap="square"/>
-                    <a:lstStyle/>
-                    <a:p>
-                      <a:pPr algn="r">
-                        <a:lnSpc>
-                          <a:spcPct val="115000"/>
-                        </a:lnSpc>
-                      </a:pPr>
-                      <a:r>
-                        <a:rPr sz="1000" b="0">
-                          <a:solidFill>
-                            <a:srgbClr val="565C66"/>
-                          </a:solidFill>
-                          <a:latin typeface="Malgun Gothic"/>
-                          <a:ea typeface="Malgun Gothic"/>
-                          <a:cs typeface="Malgun Gothic"/>
-                        </a:rPr>
-                        <a:t>0.171</a:t>
-                      </a:r>
-                    </a:p>
-                  </a:txBody>
-                  <a:tcPr marL="82296" marR="82296" marT="41148" marB="41148" anchor="ctr">
-                    <a:solidFill>
-                      <a:srgbClr val="F7F7F9"/>
-                    </a:solidFill>
-                  </a:tcPr>
-                </a:tc>
-                <a:tc>
-                  <a:txBody>
-                    <a:bodyPr wrap="square"/>
-                    <a:lstStyle/>
-                    <a:p>
-                      <a:pPr algn="r">
-                        <a:lnSpc>
-                          <a:spcPct val="115000"/>
-                        </a:lnSpc>
-                      </a:pPr>
-                      <a:r>
-                        <a:rPr sz="1000" b="0">
-                          <a:solidFill>
-                            <a:srgbClr val="565C66"/>
-                          </a:solidFill>
-                          <a:latin typeface="Malgun Gothic"/>
-                          <a:ea typeface="Malgun Gothic"/>
-                          <a:cs typeface="Malgun Gothic"/>
-                        </a:rPr>
-                        <a:t>0.114</a:t>
-                      </a:r>
-                    </a:p>
-                  </a:txBody>
-                  <a:tcPr marL="82296" marR="82296" marT="41148" marB="41148" anchor="ctr">
-                    <a:solidFill>
-                      <a:srgbClr val="F7F7F9"/>
-                    </a:solidFill>
-                  </a:tcPr>
-                </a:tc>
-                <a:tc>
-                  <a:txBody>
-                    <a:bodyPr wrap="square"/>
-                    <a:lstStyle/>
-                    <a:p>
-                      <a:pPr algn="r">
-                        <a:lnSpc>
-                          <a:spcPct val="115000"/>
-                        </a:lnSpc>
-                      </a:pPr>
-                      <a:r>
-                        <a:rPr sz="950" b="1">
-                          <a:solidFill>
-                            <a:srgbClr val="C1442A"/>
-                          </a:solidFill>
-                          <a:latin typeface="Malgun Gothic"/>
-                          <a:ea typeface="Malgun Gothic"/>
-                          <a:cs typeface="Malgun Gothic"/>
-                        </a:rPr>
-                        <a:t>0.09</a:t>
-                      </a:r>
-                    </a:p>
-                  </a:txBody>
-                  <a:tcPr marL="82296" marR="82296" marT="41148" marB="41148" anchor="ctr">
-                    <a:solidFill>
-                      <a:srgbClr val="F7F7F9"/>
-                    </a:solidFill>
-                  </a:tcPr>
-                </a:tc>
-                <a:tc>
-                  <a:txBody>
-                    <a:bodyPr wrap="square"/>
-                    <a:lstStyle/>
-                    <a:p>
-                      <a:pPr algn="ctr">
-                        <a:lnSpc>
-                          <a:spcPct val="115000"/>
-                        </a:lnSpc>
-                      </a:pPr>
-                      <a:r>
-                        <a:rPr sz="1000" b="0">
-                          <a:solidFill>
-                            <a:srgbClr val="565C66"/>
-                          </a:solidFill>
-                          <a:latin typeface="Malgun Gothic"/>
-                          <a:ea typeface="Malgun Gothic"/>
-                          <a:cs typeface="Malgun Gothic"/>
-                        </a:rPr>
-                        <a:t>0</a:t>
-                      </a:r>
-                    </a:p>
-                  </a:txBody>
-                  <a:tcPr marL="82296" marR="82296" marT="41148" marB="41148" anchor="ctr">
-                    <a:solidFill>
-                      <a:srgbClr val="F7F7F9"/>
-                    </a:solidFill>
-                  </a:tcPr>
-                </a:tc>
-                <a:tc>
-                  <a:txBody>
-                    <a:bodyPr wrap="square"/>
-                    <a:lstStyle/>
-                    <a:p>
-                      <a:pPr algn="ctr">
-                        <a:lnSpc>
-                          <a:spcPct val="115000"/>
-                        </a:lnSpc>
-                      </a:pPr>
-                      <a:r>
-                        <a:rPr sz="1000" b="0">
-                          <a:solidFill>
-                            <a:srgbClr val="565C66"/>
-                          </a:solidFill>
-                          <a:latin typeface="Malgun Gothic"/>
-                          <a:ea typeface="Malgun Gothic"/>
-                          <a:cs typeface="Malgun Gothic"/>
-                        </a:rPr>
-                        <a:t>4</a:t>
-                      </a:r>
-                    </a:p>
-                  </a:txBody>
-                  <a:tcPr marL="82296" marR="82296" marT="41148" marB="41148" anchor="ctr">
-                    <a:solidFill>
-                      <a:srgbClr val="F7F7F9"/>
-                    </a:solidFill>
-                  </a:tcPr>
-                </a:tc>
-              </a:tr>
-              <a:tr h="420624">
-                <a:tc>
-                  <a:txBody>
-                    <a:bodyPr wrap="square"/>
-                    <a:lstStyle/>
-                    <a:p>
-                      <a:pPr algn="l">
-                        <a:lnSpc>
-                          <a:spcPct val="115000"/>
-                        </a:lnSpc>
-                      </a:pPr>
-                      <a:r>
-                        <a:rPr sz="950" b="1">
-                          <a:solidFill>
-                            <a:srgbClr val="2F6FCE"/>
-                          </a:solidFill>
-                          <a:latin typeface="Malgun Gothic"/>
-                          <a:ea typeface="Malgun Gothic"/>
-                          <a:cs typeface="Malgun Gothic"/>
-                        </a:rPr>
-                        <a:t>32B bf16</a:t>
-                      </a:r>
-                    </a:p>
-                  </a:txBody>
-                  <a:tcPr marL="82296" marR="82296" marT="41148" marB="41148" anchor="ctr">
-                    <a:solidFill>
-                      <a:srgbClr val="FFFFFF"/>
-                    </a:solidFill>
-                  </a:tcPr>
-                </a:tc>
-                <a:tc>
-                  <a:txBody>
-                    <a:bodyPr wrap="square"/>
-                    <a:lstStyle/>
-                    <a:p>
-                      <a:pPr algn="l">
-                        <a:lnSpc>
-                          <a:spcPct val="115000"/>
-                        </a:lnSpc>
-                      </a:pPr>
-                      <a:r>
-                        <a:rPr sz="900" b="1">
-                          <a:solidFill>
-                            <a:srgbClr val="16181D"/>
-                          </a:solidFill>
-                          <a:latin typeface="Malgun Gothic"/>
-                          <a:ea typeface="Malgun Gothic"/>
-                          <a:cs typeface="Malgun Gothic"/>
-                        </a:rPr>
-                        <a:t>A6000 / bf16</a:t>
-                      </a:r>
-                    </a:p>
-                  </a:txBody>
-                  <a:tcPr marL="82296" marR="82296" marT="41148" marB="41148" anchor="ctr">
-                    <a:solidFill>
-                      <a:srgbClr val="FFFFFF"/>
-                    </a:solidFill>
-                  </a:tcPr>
-                </a:tc>
-                <a:tc>
-                  <a:txBody>
-                    <a:bodyPr wrap="square"/>
-                    <a:lstStyle/>
-                    <a:p>
-                      <a:pPr algn="r">
-                        <a:lnSpc>
-                          <a:spcPct val="115000"/>
-                        </a:lnSpc>
-                      </a:pPr>
-                      <a:r>
-                        <a:rPr sz="1000" b="0">
-                          <a:solidFill>
-                            <a:srgbClr val="565C66"/>
-                          </a:solidFill>
-                          <a:latin typeface="Malgun Gothic"/>
-                          <a:ea typeface="Malgun Gothic"/>
-                          <a:cs typeface="Malgun Gothic"/>
-                        </a:rPr>
-                        <a:t>0.257</a:t>
-                      </a:r>
-                    </a:p>
-                  </a:txBody>
-                  <a:tcPr marL="82296" marR="82296" marT="41148" marB="41148" anchor="ctr">
-                    <a:solidFill>
-                      <a:srgbClr val="FFFFFF"/>
-                    </a:solidFill>
-                  </a:tcPr>
-                </a:tc>
-                <a:tc>
-                  <a:txBody>
-                    <a:bodyPr wrap="square"/>
-                    <a:lstStyle/>
-                    <a:p>
-                      <a:pPr algn="r">
-                        <a:lnSpc>
-                          <a:spcPct val="115000"/>
-                        </a:lnSpc>
-                      </a:pPr>
-                      <a:r>
-                        <a:rPr sz="1000" b="1">
-                          <a:solidFill>
-                            <a:srgbClr val="C1442A"/>
-                          </a:solidFill>
-                          <a:latin typeface="Malgun Gothic"/>
-                          <a:ea typeface="Malgun Gothic"/>
-                          <a:cs typeface="Malgun Gothic"/>
-                        </a:rPr>
-                        <a:t>0.143</a:t>
-                      </a:r>
-                    </a:p>
-                  </a:txBody>
-                  <a:tcPr marL="82296" marR="82296" marT="41148" marB="41148" anchor="ctr">
-                    <a:solidFill>
-                      <a:srgbClr val="FFFFFF"/>
-                    </a:solidFill>
-                  </a:tcPr>
-                </a:tc>
-                <a:tc>
-                  <a:txBody>
-                    <a:bodyPr wrap="square"/>
-                    <a:lstStyle/>
-                    <a:p>
-                      <a:pPr algn="r">
-                        <a:lnSpc>
-                          <a:spcPct val="115000"/>
-                        </a:lnSpc>
-                      </a:pPr>
-                      <a:r>
-                        <a:rPr sz="950" b="0">
-                          <a:solidFill>
-                            <a:srgbClr val="565C66"/>
-                          </a:solidFill>
-                          <a:latin typeface="Malgun Gothic"/>
-                          <a:ea typeface="Malgun Gothic"/>
-                          <a:cs typeface="Malgun Gothic"/>
-                        </a:rPr>
-                        <a:t>0.286</a:t>
-                      </a:r>
-                    </a:p>
-                  </a:txBody>
-                  <a:tcPr marL="82296" marR="82296" marT="41148" marB="41148" anchor="ctr">
-                    <a:solidFill>
-                      <a:srgbClr val="FFFFFF"/>
-                    </a:solidFill>
-                  </a:tcPr>
-                </a:tc>
-                <a:tc>
-                  <a:txBody>
-                    <a:bodyPr wrap="square"/>
-                    <a:lstStyle/>
-                    <a:p>
-                      <a:pPr algn="ctr">
-                        <a:lnSpc>
-                          <a:spcPct val="115000"/>
-                        </a:lnSpc>
-                      </a:pPr>
-                      <a:r>
-                        <a:rPr sz="1000" b="1">
-                          <a:solidFill>
-                            <a:srgbClr val="C1442A"/>
-                          </a:solidFill>
-                          <a:latin typeface="Malgun Gothic"/>
-                          <a:ea typeface="Malgun Gothic"/>
-                          <a:cs typeface="Malgun Gothic"/>
-                        </a:rPr>
-                        <a:t>1</a:t>
-                      </a:r>
-                    </a:p>
-                  </a:txBody>
-                  <a:tcPr marL="82296" marR="82296" marT="41148" marB="41148" anchor="ctr">
-                    <a:solidFill>
-                      <a:srgbClr val="FFFFFF"/>
-                    </a:solidFill>
-                  </a:tcPr>
-                </a:tc>
-                <a:tc>
-                  <a:txBody>
-                    <a:bodyPr wrap="square"/>
-                    <a:lstStyle/>
-                    <a:p>
-                      <a:pPr algn="ctr">
-                        <a:lnSpc>
-                          <a:spcPct val="115000"/>
-                        </a:lnSpc>
-                      </a:pPr>
-                      <a:r>
-                        <a:rPr sz="1000" b="0">
-                          <a:solidFill>
-                            <a:srgbClr val="565C66"/>
-                          </a:solidFill>
-                          <a:latin typeface="Malgun Gothic"/>
-                          <a:ea typeface="Malgun Gothic"/>
-                          <a:cs typeface="Malgun Gothic"/>
-                        </a:rPr>
-                        <a:t>4</a:t>
-                      </a:r>
-                    </a:p>
-                  </a:txBody>
-                  <a:tcPr marL="82296" marR="82296" marT="41148" marB="41148" anchor="ctr">
-                    <a:solidFill>
-                      <a:srgbClr val="FFFFFF"/>
-                    </a:solidFill>
-                  </a:tcPr>
-                </a:tc>
-              </a:tr>
-              <a:tr h="420624">
-                <a:tc>
-                  <a:txBody>
-                    <a:bodyPr wrap="square"/>
-                    <a:lstStyle/>
-                    <a:p>
-                      <a:pPr algn="l">
-                        <a:lnSpc>
-                          <a:spcPct val="115000"/>
-                        </a:lnSpc>
-                      </a:pPr>
-                      <a:r>
-                        <a:rPr sz="950" b="0">
-                          <a:solidFill>
-                            <a:srgbClr val="565C66"/>
-                          </a:solidFill>
-                          <a:latin typeface="Malgun Gothic"/>
-                          <a:ea typeface="Malgun Gothic"/>
-                          <a:cs typeface="Malgun Gothic"/>
-                        </a:rPr>
-                        <a:t>(대조) 7B·8B bf16</a:t>
-                      </a:r>
-                    </a:p>
-                  </a:txBody>
-                  <a:tcPr marL="82296" marR="82296" marT="41148" marB="41148" anchor="ctr">
-                    <a:solidFill>
-                      <a:srgbClr val="F7F7F9"/>
-                    </a:solidFill>
-                  </a:tcPr>
-                </a:tc>
-                <a:tc>
-                  <a:txBody>
-                    <a:bodyPr wrap="square"/>
-                    <a:lstStyle/>
-                    <a:p>
-                      <a:pPr algn="l">
-                        <a:lnSpc>
-                          <a:spcPct val="115000"/>
-                        </a:lnSpc>
-                      </a:pPr>
-                      <a:r>
-                        <a:rPr sz="900" b="0">
-                          <a:solidFill>
-                            <a:srgbClr val="565C66"/>
-                          </a:solidFill>
-                          <a:latin typeface="Malgun Gothic"/>
-                          <a:ea typeface="Malgun Gothic"/>
-                          <a:cs typeface="Malgun Gothic"/>
-                        </a:rPr>
-                        <a:t>4090 / bf16</a:t>
-                      </a:r>
-                    </a:p>
-                  </a:txBody>
-                  <a:tcPr marL="82296" marR="82296" marT="41148" marB="41148" anchor="ctr">
-                    <a:solidFill>
-                      <a:srgbClr val="F7F7F9"/>
-                    </a:solidFill>
-                  </a:tcPr>
-                </a:tc>
-                <a:tc>
-                  <a:txBody>
-                    <a:bodyPr wrap="square"/>
-                    <a:lstStyle/>
-                    <a:p>
-                      <a:pPr algn="r">
-                        <a:lnSpc>
-                          <a:spcPct val="115000"/>
-                        </a:lnSpc>
-                      </a:pPr>
-                      <a:r>
-                        <a:rPr sz="1000" b="0">
-                          <a:solidFill>
-                            <a:srgbClr val="565C66"/>
-                          </a:solidFill>
-                          <a:latin typeface="Malgun Gothic"/>
-                          <a:ea typeface="Malgun Gothic"/>
-                          <a:cs typeface="Malgun Gothic"/>
-                        </a:rPr>
-                        <a:t>~0.18</a:t>
-                      </a:r>
-                    </a:p>
-                  </a:txBody>
-                  <a:tcPr marL="82296" marR="82296" marT="41148" marB="41148" anchor="ctr">
-                    <a:solidFill>
-                      <a:srgbClr val="F7F7F9"/>
-                    </a:solidFill>
-                  </a:tcPr>
-                </a:tc>
-                <a:tc>
-                  <a:txBody>
-                    <a:bodyPr wrap="square"/>
-                    <a:lstStyle/>
-                    <a:p>
-                      <a:pPr algn="r">
-                        <a:lnSpc>
-                          <a:spcPct val="115000"/>
-                        </a:lnSpc>
-                      </a:pPr>
-                      <a:r>
-                        <a:rPr sz="1000" b="1">
-                          <a:solidFill>
-                            <a:srgbClr val="2F6FCE"/>
-                          </a:solidFill>
-                          <a:latin typeface="Malgun Gothic"/>
-                          <a:ea typeface="Malgun Gothic"/>
-                          <a:cs typeface="Malgun Gothic"/>
-                        </a:rPr>
-                        <a:t>0.000</a:t>
-                      </a:r>
-                    </a:p>
-                  </a:txBody>
-                  <a:tcPr marL="82296" marR="82296" marT="41148" marB="41148" anchor="ctr">
-                    <a:solidFill>
-                      <a:srgbClr val="F7F7F9"/>
-                    </a:solidFill>
-                  </a:tcPr>
-                </a:tc>
-                <a:tc>
-                  <a:txBody>
-                    <a:bodyPr wrap="square"/>
-                    <a:lstStyle/>
-                    <a:p>
-                      <a:pPr algn="r">
-                        <a:lnSpc>
-                          <a:spcPct val="115000"/>
-                        </a:lnSpc>
-                      </a:pPr>
-                      <a:r>
-                        <a:rPr sz="950" b="0">
-                          <a:solidFill>
-                            <a:srgbClr val="565C66"/>
-                          </a:solidFill>
-                          <a:latin typeface="Malgun Gothic"/>
-                          <a:ea typeface="Malgun Gothic"/>
-                          <a:cs typeface="Malgun Gothic"/>
-                        </a:rPr>
-                        <a:t>0.31</a:t>
-                      </a:r>
-                    </a:p>
-                  </a:txBody>
-                  <a:tcPr marL="82296" marR="82296" marT="41148" marB="41148" anchor="ctr">
-                    <a:solidFill>
-                      <a:srgbClr val="F7F7F9"/>
-                    </a:solidFill>
-                  </a:tcPr>
-                </a:tc>
-                <a:tc>
-                  <a:txBody>
-                    <a:bodyPr wrap="square"/>
-                    <a:lstStyle/>
-                    <a:p>
-                      <a:pPr algn="ctr">
-                        <a:lnSpc>
-                          <a:spcPct val="115000"/>
-                        </a:lnSpc>
-                      </a:pPr>
-                      <a:r>
-                        <a:rPr sz="1000" b="1">
-                          <a:solidFill>
-                            <a:srgbClr val="2F6FCE"/>
-                          </a:solidFill>
-                          <a:latin typeface="Malgun Gothic"/>
-                          <a:ea typeface="Malgun Gothic"/>
-                          <a:cs typeface="Malgun Gothic"/>
-                        </a:rPr>
-                        <a:t>0</a:t>
-                      </a:r>
-                    </a:p>
-                  </a:txBody>
-                  <a:tcPr marL="82296" marR="82296" marT="41148" marB="41148" anchor="ctr">
-                    <a:solidFill>
-                      <a:srgbClr val="F7F7F9"/>
-                    </a:solidFill>
-                  </a:tcPr>
-                </a:tc>
-                <a:tc>
-                  <a:txBody>
-                    <a:bodyPr wrap="square"/>
-                    <a:lstStyle/>
-                    <a:p>
-                      <a:pPr algn="ctr">
-                        <a:lnSpc>
-                          <a:spcPct val="115000"/>
-                        </a:lnSpc>
-                      </a:pPr>
-                      <a:r>
-                        <a:rPr sz="1000" b="0">
-                          <a:solidFill>
-                            <a:srgbClr val="565C66"/>
-                          </a:solidFill>
-                          <a:latin typeface="Malgun Gothic"/>
-                          <a:ea typeface="Malgun Gothic"/>
-                          <a:cs typeface="Malgun Gothic"/>
-                        </a:rPr>
-                        <a:t>0</a:t>
-                      </a:r>
-                    </a:p>
-                  </a:txBody>
-                  <a:tcPr marL="82296" marR="82296" marT="41148" marB="41148" anchor="ctr">
-                    <a:solidFill>
-                      <a:srgbClr val="F7F7F9"/>
                     </a:solidFill>
                   </a:tcPr>
                 </a:tc>
@@ -5599,14 +6020,14 @@
       </p:graphicFrame>
       <p:sp>
         <p:nvSpPr>
-          <p:cNvPr id="6" name="Rounded Rectangle 5"/>
+          <p:cNvPr id="7" name="Rounded Rectangle 6"/>
           <p:cNvSpPr/>
           <p:nvPr/>
         </p:nvSpPr>
         <p:spPr>
           <a:xfrm>
-            <a:off x="640080" y="3931920"/>
-            <a:ext cx="10908792" cy="2148840"/>
+            <a:off x="640080" y="4526280"/>
+            <a:ext cx="10908792" cy="1783080"/>
           </a:xfrm>
           <a:prstGeom prst="roundRect">
             <a:avLst>
@@ -5643,14 +6064,14 @@
       </p:sp>
       <p:sp>
         <p:nvSpPr>
-          <p:cNvPr id="7" name="TextBox 6"/>
+          <p:cNvPr id="8" name="TextBox 7"/>
           <p:cNvSpPr txBox="1"/>
           <p:nvPr/>
         </p:nvSpPr>
         <p:spPr>
           <a:xfrm>
-            <a:off x="914400" y="4096512"/>
-            <a:ext cx="10360152" cy="1828800"/>
+            <a:off x="914400" y="4672584"/>
+            <a:ext cx="10360152" cy="1554480"/>
           </a:xfrm>
           <a:prstGeom prst="rect">
             <a:avLst/>
@@ -5669,7 +6090,7 @@
               </a:lnSpc>
             </a:pPr>
             <a:r>
-              <a:rPr sz="1150" b="1">
+              <a:rPr sz="1100" b="1">
                 <a:solidFill>
                   <a:srgbClr val="2F6FCE"/>
                 </a:solidFill>
@@ -5680,7 +6101,7 @@
               <a:t>4bit는 GPU 고정 시 결정론적</a:t>
             </a:r>
             <a:r>
-              <a:rPr sz="1150" b="0">
+              <a:rPr sz="1100" b="0">
                 <a:solidFill>
                   <a:srgbClr val="565C66"/>
                 </a:solidFill>
@@ -5688,10 +6109,10 @@
                 <a:ea typeface="Malgun Gothic"/>
                 <a:cs typeface="Malgun Gothic"/>
               </a:rPr>
-              <a:t> (7B와 동일) — A6000 3회·Blackwell 5회 각각 slack 35쌍 전부 일치. 이전에 본 "nf4dq 실행 간 12/35 불일치"는 run-to-run 노이즈가 아니라 </a:t>
-            </a:r>
-            <a:r>
-              <a:rPr sz="1150" b="1">
+              <a:t> (7B와 동일) — A6000 3회·Blackwell 5회 각각 35쌍 일치. 기존 "12/35 불일치"는 run-to-run 노이즈가 아니라 </a:t>
+            </a:r>
+            <a:r>
+              <a:rPr sz="1100" b="1">
                 <a:solidFill>
                   <a:srgbClr val="C1442A"/>
                 </a:solidFill>
@@ -5702,7 +6123,7 @@
               <a:t>A6000 ↔ Blackwell 아키텍처 차이</a:t>
             </a:r>
             <a:r>
-              <a:rPr sz="1150" b="0">
+              <a:rPr sz="1100" b="0">
                 <a:solidFill>
                   <a:srgbClr val="565C66"/>
                 </a:solidFill>
@@ -5719,11 +6140,11 @@
                 <a:spcPct val="125000"/>
               </a:lnSpc>
               <a:spcBef>
-                <a:spcPts val="700"/>
+                <a:spcPts val="600"/>
               </a:spcBef>
             </a:pPr>
             <a:r>
-              <a:rPr sz="1150" b="1">
+              <a:rPr sz="1100" b="1">
                 <a:solidFill>
                   <a:srgbClr val="C1442A"/>
                 </a:solidFill>
@@ -5734,7 +6155,7 @@
               <a:t>원인: Blackwell sm_120의 bnb nf4 커널이 32B 손상</a:t>
             </a:r>
             <a:r>
-              <a:rPr sz="1150" b="0">
+              <a:rPr sz="1100" b="0">
                 <a:solidFill>
                   <a:srgbClr val="565C66"/>
                 </a:solidFill>
@@ -5742,10 +6163,10 @@
                 <a:ea typeface="Malgun Gothic"/>
                 <a:cs typeface="Malgun Gothic"/>
               </a:rPr>
-              <a:t> — slack k0_util 0.286(=bf16) → 0.09 붕괴. → </a:t>
-            </a:r>
-            <a:r>
-              <a:rPr sz="1150" b="1">
+              <a:t> — slack k0_util 0.286(=bf16) → 0.086 붕괴. → </a:t>
+            </a:r>
+            <a:r>
+              <a:rPr sz="1100" b="1">
                 <a:solidFill>
                   <a:srgbClr val="16181D"/>
                 </a:solidFill>
@@ -5762,11 +6183,11 @@
                 <a:spcPct val="125000"/>
               </a:lnSpc>
               <a:spcBef>
-                <a:spcPts val="700"/>
+                <a:spcPts val="600"/>
               </a:spcBef>
             </a:pPr>
             <a:r>
-              <a:rPr sz="1150" b="1">
+              <a:rPr sz="1100" b="1">
                 <a:solidFill>
                   <a:srgbClr val="2F6FCE"/>
                 </a:solidFill>
@@ -5777,7 +6198,7 @@
               <a:t>스케일 효과 확정</a:t>
             </a:r>
             <a:r>
-              <a:rPr sz="1150" b="0">
+              <a:rPr sz="1100" b="0">
                 <a:solidFill>
                   <a:srgbClr val="565C66"/>
                 </a:solidFill>
@@ -5785,7 +6206,7 @@
                 <a:ea typeface="Malgun Gothic"/>
                 <a:cs typeface="Malgun Gothic"/>
               </a:rPr>
-              <a:t>: bf16(양자화 배제)에서 kN 0.143(≠0) + backfire 1 vs 7B·8B bf16 전량 억제. A6000에서 nf4dq·bf16 둘 다 8B에 못 미침.</a:t>
+              <a:t>: bf16에서 kN 0.143(≠0) + backfire 1 vs 8B 전량 억제. A6000에서 nf4dq·bf16 둘 다 8B에 못 미침.</a:t>
             </a:r>
           </a:p>
         </p:txBody>

</xml_diff>